<commit_message>
Update pitch deck: reflect completed Wokwi validation
</commit_message>
<xml_diff>
--- a/docs/Fire_Evacuation_Router_Pitch_Deck_Formal.pptx
+++ b/docs/Fire_Evacuation_Router_Pitch_Deck_Formal.pptx
@@ -1,22 +1,22 @@
 
 <file path=ppt/presentation.xml><?xml version="1.0" encoding="utf-8"?>
-<p:presentation xmlns:a="http://schemas.openxmlformats.org/drawingml/2006/main" xmlns:r="http://schemas.openxmlformats.org/officeDocument/2006/relationships" xmlns:p="http://schemas.openxmlformats.org/presentationml/2006/main" saveSubsetFonts="1" autoCompressPictures="0">
+<p:presentation xmlns:a="http://schemas.openxmlformats.org/drawingml/2006/main" xmlns:r="http://schemas.openxmlformats.org/officeDocument/2006/relationships" xmlns:p="http://schemas.openxmlformats.org/presentationml/2006/main" autoCompressPictures="0">
   <p:sldMasterIdLst>
     <p:sldMasterId id="2147483648" r:id="rId1"/>
   </p:sldMasterIdLst>
+  <p:notesMasterIdLst>
+    <p:notesMasterId r:id="rId4"/>
+  </p:notesMasterIdLst>
   <p:sldIdLst>
-    <p:sldId id="256" r:id="rId2"/>
-    <p:sldId id="257" r:id="rId3"/>
-    <p:sldId id="258" r:id="rId4"/>
-    <p:sldId id="259" r:id="rId5"/>
-    <p:sldId id="260" r:id="rId6"/>
-    <p:sldId id="261" r:id="rId7"/>
+    <p:sldId id="256" r:id="rId3"/>
+    <p:sldId id="257" r:id="rId5"/>
+    <p:sldId id="258" r:id="rId6"/>
+    <p:sldId id="259" r:id="rId7"/>
+    <p:sldId id="260" r:id="rId8"/>
+    <p:sldId id="261" r:id="rId9"/>
   </p:sldIdLst>
-  <p:notesMasterIdLst>
-    <p:notesMasterId r:id="rId8"/>
-  </p:notesMasterIdLst>
-  <p:sldSz cx="12191695" cy="6858000"/>
-  <p:notesSz cx="6858000" cy="12191695"/>
+  <p:sldSz cx="12191365" cy="6858000"/>
+  <p:notesSz cx="6858000" cy="12191365"/>
   <p:defaultTextStyle>
     <a:lvl1pPr marL="0" algn="l" defTabSz="914400" rtl="0" eaLnBrk="1" latinLnBrk="0" hangingPunct="1">
       <a:defRPr sz="1800" kern="1200">
@@ -194,7 +194,6 @@
           <a:p>
             <a:fld id="{5282F153-3F37-0F45-9E97-73ACFA13230C}" type="datetimeFigureOut">
               <a:rPr lang="en-US"/>
-              <a:t>7/23/19</a:t>
             </a:fld>
             <a:endParaRPr lang="en-US"/>
           </a:p>
@@ -261,6 +260,7 @@
               <a:rPr lang="en-US"/>
               <a:t>Click to edit Master text styles</a:t>
             </a:r>
+            <a:endParaRPr lang="en-US"/>
           </a:p>
           <a:p>
             <a:pPr lvl="1"/>
@@ -268,6 +268,7 @@
               <a:rPr lang="en-US"/>
               <a:t>Second level</a:t>
             </a:r>
+            <a:endParaRPr lang="en-US"/>
           </a:p>
           <a:p>
             <a:pPr lvl="2"/>
@@ -275,6 +276,7 @@
               <a:rPr lang="en-US"/>
               <a:t>Third level</a:t>
             </a:r>
+            <a:endParaRPr lang="en-US"/>
           </a:p>
           <a:p>
             <a:pPr lvl="3"/>
@@ -282,6 +284,7 @@
               <a:rPr lang="en-US"/>
               <a:t>Fourth level</a:t>
             </a:r>
+            <a:endParaRPr lang="en-US"/>
           </a:p>
           <a:p>
             <a:pPr lvl="4"/>
@@ -289,6 +292,7 @@
               <a:rPr lang="en-US"/>
               <a:t>Fifth level</a:t>
             </a:r>
+            <a:endParaRPr lang="en-US"/>
           </a:p>
         </p:txBody>
       </p:sp>
@@ -352,18 +356,12 @@
           <a:p>
             <a:fld id="{CE5E9CC1-C706-0F49-92D6-E571CC5EEA8F}" type="slidenum">
               <a:rPr lang="en-US"/>
-              <a:t>‹#›</a:t>
             </a:fld>
             <a:endParaRPr lang="en-US"/>
           </a:p>
         </p:txBody>
       </p:sp>
     </p:spTree>
-    <p:extLst>
-      <p:ext uri="{BB962C8B-B14F-4D97-AF65-F5344CB8AC3E}">
-        <p14:creationId xmlns:p14="http://schemas.microsoft.com/office/powerpoint/2010/main" val="1024086991"/>
-      </p:ext>
-    </p:extLst>
   </p:cSld>
   <p:clrMap bg1="lt1" tx1="dk1" bg2="lt2" tx2="dk2" accent1="accent1" accent2="accent2" accent3="accent3" accent4="accent4" accent5="accent5" accent6="accent6" hlink="hlink" folHlink="folHlink"/>
   <p:notesStyle>
@@ -505,10 +503,6 @@
           <a:bodyPr/>
           <a:lstStyle/>
           <a:p>
-            <a:r>
-              <a:rPr lang="en-US" dirty="0"/>
-              <a:t/>
-            </a:r>
             <a:endParaRPr lang="en-US" dirty="0"/>
           </a:p>
         </p:txBody>
@@ -530,18 +524,12 @@
           <a:p>
             <a:fld id="{F7021451-1387-4CA6-816F-3879F97B5CBC}" type="slidenum">
               <a:rPr lang="en-US"/>
-              <a:t>1</a:t>
             </a:fld>
             <a:endParaRPr lang="en-US"/>
           </a:p>
         </p:txBody>
       </p:sp>
     </p:spTree>
-    <p:extLst>
-      <p:ext uri="{BB962C8B-B14F-4D97-AF65-F5344CB8AC3E}">
-        <p14:creationId xmlns:p14="http://schemas.microsoft.com/office/powerpoint/2010/main" val="1024086991"/>
-      </p:ext>
-    </p:extLst>
   </p:cSld>
   <p:clrMapOvr>
     <a:masterClrMapping/>
@@ -593,10 +581,6 @@
           <a:bodyPr/>
           <a:lstStyle/>
           <a:p>
-            <a:r>
-              <a:rPr lang="en-US" dirty="0"/>
-              <a:t/>
-            </a:r>
             <a:endParaRPr lang="en-US" dirty="0"/>
           </a:p>
         </p:txBody>
@@ -618,18 +602,12 @@
           <a:p>
             <a:fld id="{F7021451-1387-4CA6-816F-3879F97B5CBC}" type="slidenum">
               <a:rPr lang="en-US"/>
-              <a:t>2</a:t>
             </a:fld>
             <a:endParaRPr lang="en-US"/>
           </a:p>
         </p:txBody>
       </p:sp>
     </p:spTree>
-    <p:extLst>
-      <p:ext uri="{BB962C8B-B14F-4D97-AF65-F5344CB8AC3E}">
-        <p14:creationId xmlns:p14="http://schemas.microsoft.com/office/powerpoint/2010/main" val="1024086991"/>
-      </p:ext>
-    </p:extLst>
   </p:cSld>
   <p:clrMapOvr>
     <a:masterClrMapping/>
@@ -681,10 +659,6 @@
           <a:bodyPr/>
           <a:lstStyle/>
           <a:p>
-            <a:r>
-              <a:rPr lang="en-US" dirty="0"/>
-              <a:t/>
-            </a:r>
             <a:endParaRPr lang="en-US" dirty="0"/>
           </a:p>
         </p:txBody>
@@ -706,18 +680,12 @@
           <a:p>
             <a:fld id="{F7021451-1387-4CA6-816F-3879F97B5CBC}" type="slidenum">
               <a:rPr lang="en-US"/>
-              <a:t>3</a:t>
             </a:fld>
             <a:endParaRPr lang="en-US"/>
           </a:p>
         </p:txBody>
       </p:sp>
     </p:spTree>
-    <p:extLst>
-      <p:ext uri="{BB962C8B-B14F-4D97-AF65-F5344CB8AC3E}">
-        <p14:creationId xmlns:p14="http://schemas.microsoft.com/office/powerpoint/2010/main" val="1024086991"/>
-      </p:ext>
-    </p:extLst>
   </p:cSld>
   <p:clrMapOvr>
     <a:masterClrMapping/>
@@ -769,10 +737,6 @@
           <a:bodyPr/>
           <a:lstStyle/>
           <a:p>
-            <a:r>
-              <a:rPr lang="en-US" dirty="0"/>
-              <a:t/>
-            </a:r>
             <a:endParaRPr lang="en-US" dirty="0"/>
           </a:p>
         </p:txBody>
@@ -794,18 +758,12 @@
           <a:p>
             <a:fld id="{F7021451-1387-4CA6-816F-3879F97B5CBC}" type="slidenum">
               <a:rPr lang="en-US"/>
-              <a:t>4</a:t>
             </a:fld>
             <a:endParaRPr lang="en-US"/>
           </a:p>
         </p:txBody>
       </p:sp>
     </p:spTree>
-    <p:extLst>
-      <p:ext uri="{BB962C8B-B14F-4D97-AF65-F5344CB8AC3E}">
-        <p14:creationId xmlns:p14="http://schemas.microsoft.com/office/powerpoint/2010/main" val="1024086991"/>
-      </p:ext>
-    </p:extLst>
   </p:cSld>
   <p:clrMapOvr>
     <a:masterClrMapping/>
@@ -857,10 +815,6 @@
           <a:bodyPr/>
           <a:lstStyle/>
           <a:p>
-            <a:r>
-              <a:rPr lang="en-US" dirty="0"/>
-              <a:t/>
-            </a:r>
             <a:endParaRPr lang="en-US" dirty="0"/>
           </a:p>
         </p:txBody>
@@ -882,18 +836,12 @@
           <a:p>
             <a:fld id="{F7021451-1387-4CA6-816F-3879F97B5CBC}" type="slidenum">
               <a:rPr lang="en-US"/>
-              <a:t>5</a:t>
             </a:fld>
             <a:endParaRPr lang="en-US"/>
           </a:p>
         </p:txBody>
       </p:sp>
     </p:spTree>
-    <p:extLst>
-      <p:ext uri="{BB962C8B-B14F-4D97-AF65-F5344CB8AC3E}">
-        <p14:creationId xmlns:p14="http://schemas.microsoft.com/office/powerpoint/2010/main" val="1024086991"/>
-      </p:ext>
-    </p:extLst>
   </p:cSld>
   <p:clrMapOvr>
     <a:masterClrMapping/>
@@ -945,10 +893,6 @@
           <a:bodyPr/>
           <a:lstStyle/>
           <a:p>
-            <a:r>
-              <a:rPr lang="en-US" dirty="0"/>
-              <a:t/>
-            </a:r>
             <a:endParaRPr lang="en-US" dirty="0"/>
           </a:p>
         </p:txBody>
@@ -970,18 +914,12 @@
           <a:p>
             <a:fld id="{F7021451-1387-4CA6-816F-3879F97B5CBC}" type="slidenum">
               <a:rPr lang="en-US"/>
-              <a:t>6</a:t>
             </a:fld>
             <a:endParaRPr lang="en-US"/>
           </a:p>
         </p:txBody>
       </p:sp>
     </p:spTree>
-    <p:extLst>
-      <p:ext uri="{BB962C8B-B14F-4D97-AF65-F5344CB8AC3E}">
-        <p14:creationId xmlns:p14="http://schemas.microsoft.com/office/powerpoint/2010/main" val="1024086991"/>
-      </p:ext>
-    </p:extLst>
   </p:cSld>
   <p:clrMapOvr>
     <a:masterClrMapping/>
@@ -1022,6 +960,11 @@
 <file path=ppt/slideMasters/slideMaster1.xml><?xml version="1.0" encoding="utf-8"?>
 <p:sldMaster xmlns:a="http://schemas.openxmlformats.org/drawingml/2006/main" xmlns:r="http://schemas.openxmlformats.org/officeDocument/2006/relationships" xmlns:p="http://schemas.openxmlformats.org/presentationml/2006/main">
   <p:cSld>
+    <p:bg>
+      <p:bgRef idx="1001">
+        <a:schemeClr val="bg1"/>
+      </p:bgRef>
+    </p:bg>
     <p:spTree>
       <p:nvGrpSpPr>
         <p:cNvPr id="1" name=""/>
@@ -1065,7 +1008,7 @@
         <a:spcBef>
           <a:spcPct val="20000"/>
         </a:spcBef>
-        <a:buFont typeface="Arial" pitchFamily="34" charset="0"/>
+        <a:buFont typeface="Arial" panose="020B0604020202020204" pitchFamily="34" charset="0"/>
         <a:buChar char="•"/>
         <a:defRPr sz="3200" kern="1200">
           <a:solidFill>
@@ -1080,7 +1023,7 @@
         <a:spcBef>
           <a:spcPct val="20000"/>
         </a:spcBef>
-        <a:buFont typeface="Arial" pitchFamily="34" charset="0"/>
+        <a:buFont typeface="Arial" panose="020B0604020202020204" pitchFamily="34" charset="0"/>
         <a:buChar char="–"/>
         <a:defRPr sz="2800" kern="1200">
           <a:solidFill>
@@ -1095,7 +1038,7 @@
         <a:spcBef>
           <a:spcPct val="20000"/>
         </a:spcBef>
-        <a:buFont typeface="Arial" pitchFamily="34" charset="0"/>
+        <a:buFont typeface="Arial" panose="020B0604020202020204" pitchFamily="34" charset="0"/>
         <a:buChar char="•"/>
         <a:defRPr sz="2400" kern="1200">
           <a:solidFill>
@@ -1110,7 +1053,7 @@
         <a:spcBef>
           <a:spcPct val="20000"/>
         </a:spcBef>
-        <a:buFont typeface="Arial" pitchFamily="34" charset="0"/>
+        <a:buFont typeface="Arial" panose="020B0604020202020204" pitchFamily="34" charset="0"/>
         <a:buChar char="–"/>
         <a:defRPr sz="2000" kern="1200">
           <a:solidFill>
@@ -1125,7 +1068,7 @@
         <a:spcBef>
           <a:spcPct val="20000"/>
         </a:spcBef>
-        <a:buFont typeface="Arial" pitchFamily="34" charset="0"/>
+        <a:buFont typeface="Arial" panose="020B0604020202020204" pitchFamily="34" charset="0"/>
         <a:buChar char="»"/>
         <a:defRPr sz="2000" kern="1200">
           <a:solidFill>
@@ -1140,7 +1083,7 @@
         <a:spcBef>
           <a:spcPct val="20000"/>
         </a:spcBef>
-        <a:buFont typeface="Arial" pitchFamily="34" charset="0"/>
+        <a:buFont typeface="Arial" panose="020B0604020202020204" pitchFamily="34" charset="0"/>
         <a:buChar char="•"/>
         <a:defRPr sz="2000" kern="1200">
           <a:solidFill>
@@ -1155,7 +1098,7 @@
         <a:spcBef>
           <a:spcPct val="20000"/>
         </a:spcBef>
-        <a:buFont typeface="Arial" pitchFamily="34" charset="0"/>
+        <a:buFont typeface="Arial" panose="020B0604020202020204" pitchFamily="34" charset="0"/>
         <a:buChar char="•"/>
         <a:defRPr sz="2000" kern="1200">
           <a:solidFill>
@@ -1170,7 +1113,7 @@
         <a:spcBef>
           <a:spcPct val="20000"/>
         </a:spcBef>
-        <a:buFont typeface="Arial" pitchFamily="34" charset="0"/>
+        <a:buFont typeface="Arial" panose="020B0604020202020204" pitchFamily="34" charset="0"/>
         <a:buChar char="•"/>
         <a:defRPr sz="2000" kern="1200">
           <a:solidFill>
@@ -1185,7 +1128,7 @@
         <a:spcBef>
           <a:spcPct val="20000"/>
         </a:spcBef>
-        <a:buFont typeface="Arial" pitchFamily="34" charset="0"/>
+        <a:buFont typeface="Arial" panose="020B0604020202020204" pitchFamily="34" charset="0"/>
         <a:buChar char="•"/>
         <a:defRPr sz="2000" kern="1200">
           <a:solidFill>
@@ -1298,12 +1241,13 @@
 
 <file path=ppt/slides/slide1.xml><?xml version="1.0" encoding="utf-8"?>
 <p:sld xmlns:a="http://schemas.openxmlformats.org/drawingml/2006/main" xmlns:r="http://schemas.openxmlformats.org/officeDocument/2006/relationships" xmlns:p="http://schemas.openxmlformats.org/presentationml/2006/main">
-  <p:cSld name="Slide 1">
+  <p:cSld>
     <p:bg>
       <p:bgPr>
         <a:solidFill>
           <a:srgbClr val="FFFFFF"/>
         </a:solidFill>
+        <a:effectLst/>
       </p:bgPr>
     </p:bg>
     <p:spTree>
@@ -1328,20 +1272,19 @@
         </p:nvSpPr>
         <p:spPr>
           <a:xfrm>
-            <a:off x="914400" y="1920240"/>
+            <a:off x="914400" y="457200"/>
             <a:ext cx="10360152" cy="1463040"/>
           </a:xfrm>
           <a:prstGeom prst="rect">
             <a:avLst/>
           </a:prstGeom>
           <a:noFill/>
-          <a:ln/>
         </p:spPr>
         <p:txBody>
           <a:bodyPr wrap="square" rtlCol="0" anchor="ctr"/>
           <a:lstStyle/>
           <a:p>
-            <a:pPr algn="ctr" indent="0" marL="0">
+            <a:pPr marL="0" indent="0" algn="ctr">
               <a:buNone/>
             </a:pPr>
             <a:r>
@@ -1349,16 +1292,16 @@
                 <a:solidFill>
                   <a:srgbClr val="1F3350"/>
                 </a:solidFill>
-                <a:latin typeface="Times New Roman" pitchFamily="34" charset="0"/>
-                <a:ea typeface="Times New Roman" pitchFamily="34" charset="-122"/>
-                <a:cs typeface="Times New Roman" pitchFamily="34" charset="-120"/>
+                <a:latin typeface="Times New Roman" panose="02020603050405020304" pitchFamily="34" charset="0"/>
+                <a:ea typeface="Times New Roman" panose="02020603050405020304" pitchFamily="34" charset="-122"/>
+                <a:cs typeface="Times New Roman" panose="02020603050405020304" pitchFamily="34" charset="-120"/>
               </a:rPr>
               <a:t>Dynamic Fire Evacuation Router with</a:t>
             </a:r>
             <a:endParaRPr lang="en-US" sz="3200" dirty="0"/>
           </a:p>
           <a:p>
-            <a:pPr algn="ctr" indent="0" marL="0">
+            <a:pPr marL="0" indent="0" algn="ctr">
               <a:buNone/>
             </a:pPr>
             <a:r>
@@ -1366,9 +1309,9 @@
                 <a:solidFill>
                   <a:srgbClr val="1F3350"/>
                 </a:solidFill>
-                <a:latin typeface="Times New Roman" pitchFamily="34" charset="0"/>
-                <a:ea typeface="Times New Roman" pitchFamily="34" charset="-122"/>
-                <a:cs typeface="Times New Roman" pitchFamily="34" charset="-120"/>
+                <a:latin typeface="Times New Roman" panose="02020603050405020304" pitchFamily="34" charset="0"/>
+                <a:ea typeface="Times New Roman" panose="02020603050405020304" pitchFamily="34" charset="-122"/>
+                <a:cs typeface="Times New Roman" panose="02020603050405020304" pitchFamily="34" charset="-120"/>
               </a:rPr>
               <a:t>Real-Time Hazard Mapping</a:t>
             </a:r>
@@ -1384,20 +1327,19 @@
         </p:nvSpPr>
         <p:spPr>
           <a:xfrm>
-            <a:off x="914400" y="3246120"/>
+            <a:off x="1002030" y="1821815"/>
             <a:ext cx="10360152" cy="457200"/>
           </a:xfrm>
           <a:prstGeom prst="rect">
             <a:avLst/>
           </a:prstGeom>
           <a:noFill/>
-          <a:ln/>
         </p:spPr>
         <p:txBody>
           <a:bodyPr wrap="square" rtlCol="0" anchor="ctr"/>
           <a:lstStyle/>
           <a:p>
-            <a:pPr algn="ctr" indent="0" marL="0">
+            <a:pPr marL="0" indent="0" algn="ctr">
               <a:buNone/>
             </a:pPr>
             <a:r>
@@ -1405,9 +1347,9 @@
                 <a:solidFill>
                   <a:srgbClr val="000000"/>
                 </a:solidFill>
-                <a:latin typeface="Times New Roman" pitchFamily="34" charset="0"/>
-                <a:ea typeface="Times New Roman" pitchFamily="34" charset="-122"/>
-                <a:cs typeface="Times New Roman" pitchFamily="34" charset="-120"/>
+                <a:latin typeface="Times New Roman" panose="02020603050405020304" pitchFamily="34" charset="0"/>
+                <a:ea typeface="Times New Roman" panose="02020603050405020304" pitchFamily="34" charset="-122"/>
+                <a:cs typeface="Times New Roman" panose="02020603050405020304" pitchFamily="34" charset="-120"/>
               </a:rPr>
               <a:t>Idea Presentation</a:t>
             </a:r>
@@ -1423,20 +1365,19 @@
         </p:nvSpPr>
         <p:spPr>
           <a:xfrm>
-            <a:off x="2103120" y="4023360"/>
+            <a:off x="2118360" y="2625725"/>
             <a:ext cx="7955280" cy="2286000"/>
           </a:xfrm>
           <a:prstGeom prst="rect">
             <a:avLst/>
           </a:prstGeom>
           <a:noFill/>
-          <a:ln/>
         </p:spPr>
         <p:txBody>
           <a:bodyPr wrap="square" rtlCol="0" anchor="t"/>
           <a:lstStyle/>
           <a:p>
-            <a:pPr algn="l" marL="342900" indent="-342900">
+            <a:pPr marL="342900" indent="-342900" algn="l">
               <a:spcAft>
                 <a:spcPts val="1000"/>
               </a:spcAft>
@@ -1444,20 +1385,31 @@
               <a:buChar char="•"/>
             </a:pPr>
             <a:r>
-              <a:rPr lang="en-US" sz="1600" dirty="0">
+              <a:rPr lang="en-US" dirty="0">
                 <a:solidFill>
                   <a:srgbClr val="000000"/>
                 </a:solidFill>
-                <a:latin typeface="Times New Roman" pitchFamily="34" charset="0"/>
-                <a:ea typeface="Times New Roman" pitchFamily="34" charset="-122"/>
-                <a:cs typeface="Times New Roman" pitchFamily="34" charset="-120"/>
-              </a:rPr>
-              <a:t>Problem Statement ID  –  [Enter Problem Statement ID]</a:t>
-            </a:r>
-            <a:endParaRPr lang="en-US" sz="1600" dirty="0"/>
-          </a:p>
-          <a:p>
-            <a:pPr algn="l" marL="342900" indent="-342900">
+                <a:latin typeface="Times New Roman" panose="02020603050405020304" pitchFamily="34" charset="0"/>
+                <a:ea typeface="Times New Roman" panose="02020603050405020304" pitchFamily="34" charset="-122"/>
+                <a:cs typeface="Times New Roman" panose="02020603050405020304" pitchFamily="34" charset="-120"/>
+              </a:rPr>
+              <a:t>Problem Statement ID  – </a:t>
+            </a:r>
+            <a:r>
+              <a:rPr lang="en-IN" altLang="en-US" dirty="0">
+                <a:solidFill>
+                  <a:srgbClr val="000000"/>
+                </a:solidFill>
+                <a:latin typeface="Times New Roman" panose="02020603050405020304" pitchFamily="34" charset="0"/>
+                <a:ea typeface="Times New Roman" panose="02020603050405020304" pitchFamily="34" charset="-122"/>
+                <a:cs typeface="Times New Roman" panose="02020603050405020304" pitchFamily="34" charset="-120"/>
+              </a:rPr>
+              <a:t>2</a:t>
+            </a:r>
+            <a:endParaRPr lang="en-US" dirty="0"/>
+          </a:p>
+          <a:p>
+            <a:pPr marL="342900" indent="-342900" algn="l">
               <a:spcAft>
                 <a:spcPts val="1000"/>
               </a:spcAft>
@@ -1465,20 +1417,20 @@
               <a:buChar char="•"/>
             </a:pPr>
             <a:r>
-              <a:rPr lang="en-US" sz="1600" dirty="0">
+              <a:rPr lang="en-US" dirty="0">
                 <a:solidFill>
                   <a:srgbClr val="000000"/>
                 </a:solidFill>
-                <a:latin typeface="Times New Roman" pitchFamily="34" charset="0"/>
-                <a:ea typeface="Times New Roman" pitchFamily="34" charset="-122"/>
-                <a:cs typeface="Times New Roman" pitchFamily="34" charset="-120"/>
+                <a:latin typeface="Times New Roman" panose="02020603050405020304" pitchFamily="34" charset="0"/>
+                <a:ea typeface="Times New Roman" panose="02020603050405020304" pitchFamily="34" charset="-122"/>
+                <a:cs typeface="Times New Roman" panose="02020603050405020304" pitchFamily="34" charset="-120"/>
               </a:rPr>
               <a:t>Problem Statement Title  –  Dynamic Fire Evacuation Router with Real-Time Hazard Mapping</a:t>
             </a:r>
-            <a:endParaRPr lang="en-US" sz="1600" dirty="0"/>
-          </a:p>
-          <a:p>
-            <a:pPr algn="l" marL="342900" indent="-342900">
+            <a:endParaRPr lang="en-US" dirty="0"/>
+          </a:p>
+          <a:p>
+            <a:pPr marL="342900" indent="-342900" algn="l">
               <a:spcAft>
                 <a:spcPts val="1000"/>
               </a:spcAft>
@@ -1486,20 +1438,20 @@
               <a:buChar char="•"/>
             </a:pPr>
             <a:r>
-              <a:rPr lang="en-US" sz="1600" dirty="0">
+              <a:rPr lang="en-US" dirty="0">
                 <a:solidFill>
                   <a:srgbClr val="000000"/>
                 </a:solidFill>
-                <a:latin typeface="Times New Roman" pitchFamily="34" charset="0"/>
-                <a:ea typeface="Times New Roman" pitchFamily="34" charset="-122"/>
-                <a:cs typeface="Times New Roman" pitchFamily="34" charset="-120"/>
+                <a:latin typeface="Times New Roman" panose="02020603050405020304" pitchFamily="34" charset="0"/>
+                <a:ea typeface="Times New Roman" panose="02020603050405020304" pitchFamily="34" charset="-122"/>
+                <a:cs typeface="Times New Roman" panose="02020603050405020304" pitchFamily="34" charset="-120"/>
               </a:rPr>
               <a:t>Theme  –  IoT and Real-Time Embedded Systems for Life Safety</a:t>
             </a:r>
-            <a:endParaRPr lang="en-US" sz="1600" dirty="0"/>
-          </a:p>
-          <a:p>
-            <a:pPr algn="l" marL="342900" indent="-342900">
+            <a:endParaRPr lang="en-US" dirty="0"/>
+          </a:p>
+          <a:p>
+            <a:pPr marL="342900" indent="-342900" algn="l">
               <a:spcAft>
                 <a:spcPts val="1000"/>
               </a:spcAft>
@@ -1507,20 +1459,20 @@
               <a:buChar char="•"/>
             </a:pPr>
             <a:r>
-              <a:rPr lang="en-US" sz="1600" dirty="0">
+              <a:rPr lang="en-US" dirty="0">
                 <a:solidFill>
                   <a:srgbClr val="000000"/>
                 </a:solidFill>
-                <a:latin typeface="Times New Roman" pitchFamily="34" charset="0"/>
-                <a:ea typeface="Times New Roman" pitchFamily="34" charset="-122"/>
-                <a:cs typeface="Times New Roman" pitchFamily="34" charset="-120"/>
+                <a:latin typeface="Times New Roman" panose="02020603050405020304" pitchFamily="34" charset="0"/>
+                <a:ea typeface="Times New Roman" panose="02020603050405020304" pitchFamily="34" charset="-122"/>
+                <a:cs typeface="Times New Roman" panose="02020603050405020304" pitchFamily="34" charset="-120"/>
               </a:rPr>
               <a:t>PS Category  –  Software</a:t>
             </a:r>
-            <a:endParaRPr lang="en-US" sz="1600" dirty="0"/>
-          </a:p>
-          <a:p>
-            <a:pPr algn="l" marL="342900" indent="-342900">
+            <a:endParaRPr lang="en-US" dirty="0"/>
+          </a:p>
+          <a:p>
+            <a:pPr marL="342900" indent="-342900" algn="l">
               <a:spcAft>
                 <a:spcPts val="1000"/>
               </a:spcAft>
@@ -1528,20 +1480,20 @@
               <a:buChar char="•"/>
             </a:pPr>
             <a:r>
-              <a:rPr lang="en-US" sz="1600" dirty="0">
+              <a:rPr lang="en-US" dirty="0">
                 <a:solidFill>
                   <a:srgbClr val="000000"/>
                 </a:solidFill>
-                <a:latin typeface="Times New Roman" pitchFamily="34" charset="0"/>
-                <a:ea typeface="Times New Roman" pitchFamily="34" charset="-122"/>
-                <a:cs typeface="Times New Roman" pitchFamily="34" charset="-120"/>
+                <a:latin typeface="Times New Roman" panose="02020603050405020304" pitchFamily="34" charset="0"/>
+                <a:ea typeface="Times New Roman" panose="02020603050405020304" pitchFamily="34" charset="-122"/>
+                <a:cs typeface="Times New Roman" panose="02020603050405020304" pitchFamily="34" charset="-120"/>
               </a:rPr>
               <a:t>Student Name  –  Kishaunjith S</a:t>
             </a:r>
-            <a:endParaRPr lang="en-US" sz="1600" dirty="0"/>
-          </a:p>
-          <a:p>
-            <a:pPr algn="l" marL="342900" indent="-342900">
+            <a:endParaRPr lang="en-US" dirty="0"/>
+          </a:p>
+          <a:p>
+            <a:pPr marL="342900" indent="-342900" algn="l">
               <a:spcAft>
                 <a:spcPts val="1000"/>
               </a:spcAft>
@@ -1549,17 +1501,35 @@
               <a:buChar char="•"/>
             </a:pPr>
             <a:r>
-              <a:rPr lang="en-US" sz="1600" dirty="0">
+              <a:rPr lang="en-US" dirty="0">
                 <a:solidFill>
                   <a:srgbClr val="000000"/>
                 </a:solidFill>
-                <a:latin typeface="Times New Roman" pitchFamily="34" charset="0"/>
-                <a:ea typeface="Times New Roman" pitchFamily="34" charset="-122"/>
-                <a:cs typeface="Times New Roman" pitchFamily="34" charset="-120"/>
-              </a:rPr>
-              <a:t>Student ID  –  [Enter Student ID]</a:t>
-            </a:r>
-            <a:endParaRPr lang="en-US" sz="1600" dirty="0"/>
+                <a:latin typeface="Times New Roman" panose="02020603050405020304" pitchFamily="34" charset="0"/>
+                <a:ea typeface="Times New Roman" panose="02020603050405020304" pitchFamily="34" charset="-122"/>
+                <a:cs typeface="Times New Roman" panose="02020603050405020304" pitchFamily="34" charset="-120"/>
+              </a:rPr>
+              <a:t>Student ID  –  </a:t>
+            </a:r>
+            <a:r>
+              <a:rPr lang="en-IN" altLang="en-US" dirty="0">
+                <a:solidFill>
+                  <a:srgbClr val="000000"/>
+                </a:solidFill>
+                <a:latin typeface="Times New Roman" panose="02020603050405020304" pitchFamily="34" charset="0"/>
+                <a:ea typeface="Times New Roman" panose="02020603050405020304" pitchFamily="34" charset="-122"/>
+                <a:cs typeface="Times New Roman" panose="02020603050405020304" pitchFamily="34" charset="-120"/>
+              </a:rPr>
+              <a:t>23BCE1857</a:t>
+            </a:r>
+            <a:endParaRPr lang="en-IN" altLang="en-US" dirty="0">
+              <a:solidFill>
+                <a:srgbClr val="000000"/>
+              </a:solidFill>
+              <a:latin typeface="Times New Roman" panose="02020603050405020304" pitchFamily="34" charset="0"/>
+              <a:ea typeface="Times New Roman" panose="02020603050405020304" pitchFamily="34" charset="-122"/>
+              <a:cs typeface="Times New Roman" panose="02020603050405020304" pitchFamily="34" charset="-120"/>
+            </a:endParaRPr>
           </a:p>
         </p:txBody>
       </p:sp>
@@ -1578,13 +1548,12 @@
             <a:avLst/>
           </a:prstGeom>
           <a:noFill/>
-          <a:ln/>
         </p:spPr>
         <p:txBody>
           <a:bodyPr wrap="square" rtlCol="0" anchor="ctr"/>
           <a:lstStyle/>
           <a:p>
-            <a:pPr algn="l" indent="0" marL="0">
+            <a:pPr marL="0" indent="0" algn="l">
               <a:buNone/>
             </a:pPr>
             <a:r>
@@ -1592,9 +1561,9 @@
                 <a:solidFill>
                   <a:srgbClr val="1F3350"/>
                 </a:solidFill>
-                <a:latin typeface="Times New Roman" pitchFamily="34" charset="0"/>
-                <a:ea typeface="Times New Roman" pitchFamily="34" charset="-122"/>
-                <a:cs typeface="Times New Roman" pitchFamily="34" charset="-120"/>
+                <a:latin typeface="Times New Roman" panose="02020603050405020304" pitchFamily="34" charset="0"/>
+                <a:ea typeface="Times New Roman" panose="02020603050405020304" pitchFamily="34" charset="-122"/>
+                <a:cs typeface="Times New Roman" panose="02020603050405020304" pitchFamily="34" charset="-120"/>
               </a:rPr>
               <a:t>Dynamic Fire Evacuation Router</a:t>
             </a:r>
@@ -1617,13 +1586,12 @@
             <a:avLst/>
           </a:prstGeom>
           <a:noFill/>
-          <a:ln/>
         </p:spPr>
         <p:txBody>
           <a:bodyPr wrap="square" rtlCol="0" anchor="ctr"/>
           <a:lstStyle/>
           <a:p>
-            <a:pPr algn="r" indent="0" marL="0">
+            <a:pPr marL="0" indent="0" algn="r">
               <a:buNone/>
             </a:pPr>
             <a:r>
@@ -1631,9 +1599,9 @@
                 <a:solidFill>
                   <a:srgbClr val="1F3350"/>
                 </a:solidFill>
-                <a:latin typeface="Times New Roman" pitchFamily="34" charset="0"/>
-                <a:ea typeface="Times New Roman" pitchFamily="34" charset="-122"/>
-                <a:cs typeface="Times New Roman" pitchFamily="34" charset="-120"/>
+                <a:latin typeface="Times New Roman" panose="02020603050405020304" pitchFamily="34" charset="0"/>
+                <a:ea typeface="Times New Roman" panose="02020603050405020304" pitchFamily="34" charset="-122"/>
+                <a:cs typeface="Times New Roman" panose="02020603050405020304" pitchFamily="34" charset="-120"/>
               </a:rPr>
               <a:t>1</a:t>
             </a:r>
@@ -1651,12 +1619,13 @@
 
 <file path=ppt/slides/slide2.xml><?xml version="1.0" encoding="utf-8"?>
 <p:sld xmlns:a="http://schemas.openxmlformats.org/drawingml/2006/main" xmlns:r="http://schemas.openxmlformats.org/officeDocument/2006/relationships" xmlns:p="http://schemas.openxmlformats.org/presentationml/2006/main">
-  <p:cSld name="Slide 2">
+  <p:cSld>
     <p:bg>
       <p:bgPr>
         <a:solidFill>
           <a:srgbClr val="FFFFFF"/>
         </a:solidFill>
+        <a:effectLst/>
       </p:bgPr>
     </p:bg>
     <p:spTree>
@@ -1688,13 +1657,12 @@
             <a:avLst/>
           </a:prstGeom>
           <a:noFill/>
-          <a:ln/>
         </p:spPr>
         <p:txBody>
           <a:bodyPr wrap="square" rtlCol="0" anchor="ctr"/>
           <a:lstStyle/>
           <a:p>
-            <a:pPr algn="l" indent="0" marL="0">
+            <a:pPr marL="0" indent="0" algn="l">
               <a:buNone/>
             </a:pPr>
             <a:r>
@@ -1702,9 +1670,9 @@
                 <a:solidFill>
                   <a:srgbClr val="1F3350"/>
                 </a:solidFill>
-                <a:latin typeface="Times New Roman" pitchFamily="34" charset="0"/>
-                <a:ea typeface="Times New Roman" pitchFamily="34" charset="-122"/>
-                <a:cs typeface="Times New Roman" pitchFamily="34" charset="-120"/>
+                <a:latin typeface="Times New Roman" panose="02020603050405020304" pitchFamily="34" charset="0"/>
+                <a:ea typeface="Times New Roman" panose="02020603050405020304" pitchFamily="34" charset="-122"/>
+                <a:cs typeface="Times New Roman" panose="02020603050405020304" pitchFamily="34" charset="-120"/>
               </a:rPr>
               <a:t>Proposed solution</a:t>
             </a:r>
@@ -1727,13 +1695,12 @@
             <a:avLst/>
           </a:prstGeom>
           <a:noFill/>
-          <a:ln/>
         </p:spPr>
         <p:txBody>
           <a:bodyPr wrap="square" rtlCol="0" anchor="ctr"/>
           <a:lstStyle/>
           <a:p>
-            <a:pPr indent="0" marL="0">
+            <a:pPr marL="0" indent="0">
               <a:buNone/>
             </a:pPr>
             <a:r>
@@ -1741,9 +1708,9 @@
                 <a:solidFill>
                   <a:srgbClr val="000000"/>
                 </a:solidFill>
-                <a:latin typeface="Times New Roman" pitchFamily="34" charset="0"/>
-                <a:ea typeface="Times New Roman" pitchFamily="34" charset="-122"/>
-                <a:cs typeface="Times New Roman" pitchFamily="34" charset="-120"/>
+                <a:latin typeface="Times New Roman" panose="02020603050405020304" pitchFamily="34" charset="0"/>
+                <a:ea typeface="Times New Roman" panose="02020603050405020304" pitchFamily="34" charset="-122"/>
+                <a:cs typeface="Times New Roman" panose="02020603050405020304" pitchFamily="34" charset="-120"/>
               </a:rPr>
               <a:t>Idea title: Dynamic Fire Evacuation Router with Real-Time Hazard Mapping</a:t>
             </a:r>
@@ -1766,13 +1733,12 @@
             <a:avLst/>
           </a:prstGeom>
           <a:noFill/>
-          <a:ln/>
         </p:spPr>
         <p:txBody>
           <a:bodyPr wrap="square" rtlCol="0" anchor="t"/>
           <a:lstStyle/>
           <a:p>
-            <a:pPr algn="l" marL="342900" indent="-342900">
+            <a:pPr marL="342900" indent="-342900" algn="l">
               <a:spcAft>
                 <a:spcPts val="1600"/>
               </a:spcAft>
@@ -1784,16 +1750,16 @@
                 <a:solidFill>
                   <a:srgbClr val="000000"/>
                 </a:solidFill>
-                <a:latin typeface="Times New Roman" pitchFamily="34" charset="0"/>
-                <a:ea typeface="Times New Roman" pitchFamily="34" charset="-122"/>
-                <a:cs typeface="Times New Roman" pitchFamily="34" charset="-120"/>
+                <a:latin typeface="Times New Roman" panose="02020603050405020304" pitchFamily="34" charset="0"/>
+                <a:ea typeface="Times New Roman" panose="02020603050405020304" pitchFamily="34" charset="-122"/>
+                <a:cs typeface="Times New Roman" panose="02020603050405020304" pitchFamily="34" charset="-120"/>
               </a:rPr>
               <a:t>Decentralized, MQTT-based system senses, fuses, and reroutes live</a:t>
             </a:r>
             <a:endParaRPr lang="en-US" sz="2000" dirty="0"/>
           </a:p>
           <a:p>
-            <a:pPr algn="l" marL="342900" indent="-342900">
+            <a:pPr marL="342900" indent="-342900" algn="l">
               <a:spcAft>
                 <a:spcPts val="1600"/>
               </a:spcAft>
@@ -1805,16 +1771,16 @@
                 <a:solidFill>
                   <a:srgbClr val="000000"/>
                 </a:solidFill>
-                <a:latin typeface="Times New Roman" pitchFamily="34" charset="0"/>
-                <a:ea typeface="Times New Roman" pitchFamily="34" charset="-122"/>
-                <a:cs typeface="Times New Roman" pitchFamily="34" charset="-120"/>
+                <a:latin typeface="Times New Roman" panose="02020603050405020304" pitchFamily="34" charset="0"/>
+                <a:ea typeface="Times New Roman" panose="02020603050405020304" pitchFamily="34" charset="-122"/>
+                <a:cs typeface="Times New Roman" panose="02020603050405020304" pitchFamily="34" charset="-120"/>
               </a:rPr>
               <a:t>Non-linear sensor fusion feeds one centralized Dijkstra routing pass</a:t>
             </a:r>
             <a:endParaRPr lang="en-US" sz="2000" dirty="0"/>
           </a:p>
           <a:p>
-            <a:pPr algn="l" marL="342900" indent="-342900">
+            <a:pPr marL="342900" indent="-342900" algn="l">
               <a:spcAft>
                 <a:spcPts val="1600"/>
               </a:spcAft>
@@ -1826,16 +1792,16 @@
                 <a:solidFill>
                   <a:srgbClr val="000000"/>
                 </a:solidFill>
-                <a:latin typeface="Times New Roman" pitchFamily="34" charset="0"/>
-                <a:ea typeface="Times New Roman" pitchFamily="34" charset="-122"/>
-                <a:cs typeface="Times New Roman" pitchFamily="34" charset="-120"/>
+                <a:latin typeface="Times New Roman" panose="02020603050405020304" pitchFamily="34" charset="0"/>
+                <a:ea typeface="Times New Roman" panose="02020603050405020304" pitchFamily="34" charset="-122"/>
+                <a:cs typeface="Times New Roman" panose="02020603050405020304" pitchFamily="34" charset="-120"/>
               </a:rPr>
               <a:t>Broadcasts safest exit direction to every zone within 300 ms</a:t>
             </a:r>
             <a:endParaRPr lang="en-US" sz="2000" dirty="0"/>
           </a:p>
           <a:p>
-            <a:pPr algn="l" marL="342900" indent="-342900">
+            <a:pPr marL="342900" indent="-342900" algn="l">
               <a:spcAft>
                 <a:spcPts val="1600"/>
               </a:spcAft>
@@ -1847,16 +1813,16 @@
                 <a:solidFill>
                   <a:srgbClr val="000000"/>
                 </a:solidFill>
-                <a:latin typeface="Times New Roman" pitchFamily="34" charset="0"/>
-                <a:ea typeface="Times New Roman" pitchFamily="34" charset="-122"/>
-                <a:cs typeface="Times New Roman" pitchFamily="34" charset="-120"/>
+                <a:latin typeface="Times New Roman" panose="02020603050405020304" pitchFamily="34" charset="0"/>
+                <a:ea typeface="Times New Roman" panose="02020603050405020304" pitchFamily="34" charset="-122"/>
+                <a:cs typeface="Times New Roman" panose="02020603050405020304" pitchFamily="34" charset="-120"/>
               </a:rPr>
               <a:t>Replaces static exit signage with live-recalculated LED guidance</a:t>
             </a:r>
             <a:endParaRPr lang="en-US" sz="2000" dirty="0"/>
           </a:p>
           <a:p>
-            <a:pPr algn="l" marL="342900" indent="-342900">
+            <a:pPr marL="342900" indent="-342900" algn="l">
               <a:spcAft>
                 <a:spcPts val="1600"/>
               </a:spcAft>
@@ -1868,16 +1834,16 @@
                 <a:solidFill>
                   <a:srgbClr val="000000"/>
                 </a:solidFill>
-                <a:latin typeface="Times New Roman" pitchFamily="34" charset="0"/>
-                <a:ea typeface="Times New Roman" pitchFamily="34" charset="-122"/>
-                <a:cs typeface="Times New Roman" pitchFamily="34" charset="-120"/>
+                <a:latin typeface="Times New Roman" panose="02020603050405020304" pitchFamily="34" charset="0"/>
+                <a:ea typeface="Times New Roman" panose="02020603050405020304" pitchFamily="34" charset="-122"/>
+                <a:cs typeface="Times New Roman" panose="02020603050405020304" pitchFamily="34" charset="-120"/>
               </a:rPr>
               <a:t>Falls back to shelter-in-place when no safe path exists</a:t>
             </a:r>
             <a:endParaRPr lang="en-US" sz="2000" dirty="0"/>
           </a:p>
           <a:p>
-            <a:pPr algn="l" marL="342900" indent="-342900">
+            <a:pPr marL="342900" indent="-342900" algn="l">
               <a:spcAft>
                 <a:spcPts val="1600"/>
               </a:spcAft>
@@ -1889,9 +1855,9 @@
                 <a:solidFill>
                   <a:srgbClr val="000000"/>
                 </a:solidFill>
-                <a:latin typeface="Times New Roman" pitchFamily="34" charset="0"/>
-                <a:ea typeface="Times New Roman" pitchFamily="34" charset="-122"/>
-                <a:cs typeface="Times New Roman" pitchFamily="34" charset="-120"/>
+                <a:latin typeface="Times New Roman" panose="02020603050405020304" pitchFamily="34" charset="0"/>
+                <a:ea typeface="Times New Roman" panose="02020603050405020304" pitchFamily="34" charset="-122"/>
+                <a:cs typeface="Times New Roman" panose="02020603050405020304" pitchFamily="34" charset="-120"/>
               </a:rPr>
               <a:t>Validated under real load testing, not just a single demo</a:t>
             </a:r>
@@ -1914,13 +1880,12 @@
             <a:avLst/>
           </a:prstGeom>
           <a:noFill/>
-          <a:ln/>
         </p:spPr>
         <p:txBody>
           <a:bodyPr wrap="square" rtlCol="0" anchor="ctr"/>
           <a:lstStyle/>
           <a:p>
-            <a:pPr algn="l" indent="0" marL="0">
+            <a:pPr marL="0" indent="0" algn="l">
               <a:buNone/>
             </a:pPr>
             <a:r>
@@ -1928,9 +1893,9 @@
                 <a:solidFill>
                   <a:srgbClr val="1F3350"/>
                 </a:solidFill>
-                <a:latin typeface="Times New Roman" pitchFamily="34" charset="0"/>
-                <a:ea typeface="Times New Roman" pitchFamily="34" charset="-122"/>
-                <a:cs typeface="Times New Roman" pitchFamily="34" charset="-120"/>
+                <a:latin typeface="Times New Roman" panose="02020603050405020304" pitchFamily="34" charset="0"/>
+                <a:ea typeface="Times New Roman" panose="02020603050405020304" pitchFamily="34" charset="-122"/>
+                <a:cs typeface="Times New Roman" panose="02020603050405020304" pitchFamily="34" charset="-120"/>
               </a:rPr>
               <a:t>Dynamic Fire Evacuation Router</a:t>
             </a:r>
@@ -1953,13 +1918,12 @@
             <a:avLst/>
           </a:prstGeom>
           <a:noFill/>
-          <a:ln/>
         </p:spPr>
         <p:txBody>
           <a:bodyPr wrap="square" rtlCol="0" anchor="ctr"/>
           <a:lstStyle/>
           <a:p>
-            <a:pPr algn="r" indent="0" marL="0">
+            <a:pPr marL="0" indent="0" algn="r">
               <a:buNone/>
             </a:pPr>
             <a:r>
@@ -1967,9 +1931,9 @@
                 <a:solidFill>
                   <a:srgbClr val="1F3350"/>
                 </a:solidFill>
-                <a:latin typeface="Times New Roman" pitchFamily="34" charset="0"/>
-                <a:ea typeface="Times New Roman" pitchFamily="34" charset="-122"/>
-                <a:cs typeface="Times New Roman" pitchFamily="34" charset="-120"/>
+                <a:latin typeface="Times New Roman" panose="02020603050405020304" pitchFamily="34" charset="0"/>
+                <a:ea typeface="Times New Roman" panose="02020603050405020304" pitchFamily="34" charset="-122"/>
+                <a:cs typeface="Times New Roman" panose="02020603050405020304" pitchFamily="34" charset="-120"/>
               </a:rPr>
               <a:t>2</a:t>
             </a:r>
@@ -1987,12 +1951,13 @@
 
 <file path=ppt/slides/slide3.xml><?xml version="1.0" encoding="utf-8"?>
 <p:sld xmlns:a="http://schemas.openxmlformats.org/drawingml/2006/main" xmlns:r="http://schemas.openxmlformats.org/officeDocument/2006/relationships" xmlns:p="http://schemas.openxmlformats.org/presentationml/2006/main">
-  <p:cSld name="Slide 3">
+  <p:cSld>
     <p:bg>
       <p:bgPr>
         <a:solidFill>
           <a:srgbClr val="FFFFFF"/>
         </a:solidFill>
+        <a:effectLst/>
       </p:bgPr>
     </p:bg>
     <p:spTree>
@@ -2024,13 +1989,12 @@
             <a:avLst/>
           </a:prstGeom>
           <a:noFill/>
-          <a:ln/>
         </p:spPr>
         <p:txBody>
           <a:bodyPr wrap="square" rtlCol="0" anchor="ctr"/>
           <a:lstStyle/>
           <a:p>
-            <a:pPr algn="l" indent="0" marL="0">
+            <a:pPr marL="0" indent="0" algn="l">
               <a:buNone/>
             </a:pPr>
             <a:r>
@@ -2038,9 +2002,9 @@
                 <a:solidFill>
                   <a:srgbClr val="1F3350"/>
                 </a:solidFill>
-                <a:latin typeface="Times New Roman" pitchFamily="34" charset="0"/>
-                <a:ea typeface="Times New Roman" pitchFamily="34" charset="-122"/>
-                <a:cs typeface="Times New Roman" pitchFamily="34" charset="-120"/>
+                <a:latin typeface="Times New Roman" panose="02020603050405020304" pitchFamily="34" charset="0"/>
+                <a:ea typeface="Times New Roman" panose="02020603050405020304" pitchFamily="34" charset="-122"/>
+                <a:cs typeface="Times New Roman" panose="02020603050405020304" pitchFamily="34" charset="-120"/>
               </a:rPr>
               <a:t>Technical approach</a:t>
             </a:r>
@@ -2063,13 +2027,12 @@
             <a:avLst/>
           </a:prstGeom>
           <a:noFill/>
-          <a:ln/>
         </p:spPr>
         <p:txBody>
           <a:bodyPr wrap="square" rtlCol="0" anchor="t"/>
           <a:lstStyle/>
           <a:p>
-            <a:pPr algn="l" marL="342900" indent="-342900">
+            <a:pPr marL="342900" indent="-342900" algn="l">
               <a:spcAft>
                 <a:spcPts val="1200"/>
               </a:spcAft>
@@ -2081,16 +2044,16 @@
                 <a:solidFill>
                   <a:srgbClr val="000000"/>
                 </a:solidFill>
-                <a:latin typeface="Times New Roman" pitchFamily="34" charset="0"/>
-                <a:ea typeface="Times New Roman" pitchFamily="34" charset="-122"/>
-                <a:cs typeface="Times New Roman" pitchFamily="34" charset="-120"/>
+                <a:latin typeface="Times New Roman" panose="02020603050405020304" pitchFamily="34" charset="0"/>
+                <a:ea typeface="Times New Roman" panose="02020603050405020304" pitchFamily="34" charset="-122"/>
+                <a:cs typeface="Times New Roman" panose="02020603050405020304" pitchFamily="34" charset="-120"/>
               </a:rPr>
               <a:t>Python: Flask, NetworkX, paho-mqtt for core routing logic</a:t>
             </a:r>
             <a:endParaRPr lang="en-US" sz="1900" dirty="0"/>
           </a:p>
           <a:p>
-            <a:pPr algn="l" marL="342900" indent="-342900">
+            <a:pPr marL="342900" indent="-342900" algn="l">
               <a:spcAft>
                 <a:spcPts val="1200"/>
               </a:spcAft>
@@ -2102,16 +2065,16 @@
                 <a:solidFill>
                   <a:srgbClr val="000000"/>
                 </a:solidFill>
-                <a:latin typeface="Times New Roman" pitchFamily="34" charset="0"/>
-                <a:ea typeface="Times New Roman" pitchFamily="34" charset="-122"/>
-                <a:cs typeface="Times New Roman" pitchFamily="34" charset="-120"/>
+                <a:latin typeface="Times New Roman" panose="02020603050405020304" pitchFamily="34" charset="0"/>
+                <a:ea typeface="Times New Roman" panose="02020603050405020304" pitchFamily="34" charset="-122"/>
+                <a:cs typeface="Times New Roman" panose="02020603050405020304" pitchFamily="34" charset="-120"/>
               </a:rPr>
               <a:t>Mosquitto MQTT broker; Node-RED for monitoring dashboard</a:t>
             </a:r>
             <a:endParaRPr lang="en-US" sz="1900" dirty="0"/>
           </a:p>
           <a:p>
-            <a:pPr algn="l" marL="342900" indent="-342900">
+            <a:pPr marL="342900" indent="-342900" algn="l">
               <a:spcAft>
                 <a:spcPts val="1200"/>
               </a:spcAft>
@@ -2123,16 +2086,16 @@
                 <a:solidFill>
                   <a:srgbClr val="000000"/>
                 </a:solidFill>
-                <a:latin typeface="Times New Roman" pitchFamily="34" charset="0"/>
-                <a:ea typeface="Times New Roman" pitchFamily="34" charset="-122"/>
-                <a:cs typeface="Times New Roman" pitchFamily="34" charset="-120"/>
+                <a:latin typeface="Times New Roman" panose="02020603050405020304" pitchFamily="34" charset="0"/>
+                <a:ea typeface="Times New Roman" panose="02020603050405020304" pitchFamily="34" charset="-122"/>
+                <a:cs typeface="Times New Roman" panose="02020603050405020304" pitchFamily="34" charset="-120"/>
               </a:rPr>
               <a:t>HTML, CSS, JavaScript control panel; Web Audio API alarm</a:t>
             </a:r>
             <a:endParaRPr lang="en-US" sz="1900" dirty="0"/>
           </a:p>
           <a:p>
-            <a:pPr algn="l" marL="342900" indent="-342900">
+            <a:pPr marL="342900" indent="-342900" algn="l">
               <a:spcAft>
                 <a:spcPts val="1200"/>
               </a:spcAft>
@@ -2144,11 +2107,11 @@
                 <a:solidFill>
                   <a:srgbClr val="000000"/>
                 </a:solidFill>
-                <a:latin typeface="Times New Roman" pitchFamily="34" charset="0"/>
-                <a:ea typeface="Times New Roman" pitchFamily="34" charset="-122"/>
-                <a:cs typeface="Times New Roman" pitchFamily="34" charset="-120"/>
-              </a:rPr>
-              <a:t>Hardware-ready: ESP32 with DHT22, MQ-2, and IR sensors</a:t>
+                <a:latin typeface="Times New Roman" panose="02020603050405020304" pitchFamily="34" charset="0"/>
+                <a:ea typeface="Times New Roman" panose="02020603050405020304" pitchFamily="34" charset="-122"/>
+                <a:cs typeface="Times New Roman" panose="02020603050405020304" pitchFamily="34" charset="-120"/>
+              </a:rPr>
+              <a:t>Fusion formula validated on real ESP32 firmware (Wokwi simulation)</a:t>
             </a:r>
             <a:endParaRPr lang="en-US" sz="1900" dirty="0"/>
           </a:p>
@@ -2169,13 +2132,12 @@
             <a:avLst/>
           </a:prstGeom>
           <a:noFill/>
-          <a:ln/>
         </p:spPr>
         <p:txBody>
           <a:bodyPr wrap="square" rtlCol="0" anchor="ctr"/>
           <a:lstStyle/>
           <a:p>
-            <a:pPr algn="ctr" indent="0" marL="0">
+            <a:pPr marL="0" indent="0" algn="ctr">
               <a:buNone/>
             </a:pPr>
             <a:r>
@@ -2183,9 +2145,9 @@
                 <a:solidFill>
                   <a:srgbClr val="1F3350"/>
                 </a:solidFill>
-                <a:latin typeface="Times New Roman" pitchFamily="34" charset="0"/>
-                <a:ea typeface="Times New Roman" pitchFamily="34" charset="-122"/>
-                <a:cs typeface="Times New Roman" pitchFamily="34" charset="-120"/>
+                <a:latin typeface="Times New Roman" panose="02020603050405020304" pitchFamily="34" charset="0"/>
+                <a:ea typeface="Times New Roman" panose="02020603050405020304" pitchFamily="34" charset="-122"/>
+                <a:cs typeface="Times New Roman" panose="02020603050405020304" pitchFamily="34" charset="-120"/>
               </a:rPr>
               <a:t>Figure 1. Sensor-to-dashboard system pipeline</a:t>
             </a:r>
@@ -2195,7 +2157,7 @@
       </p:sp>
       <p:pic>
         <p:nvPicPr>
-          <p:cNvPr id="5" name="Image 0" descr="/home/claude/pitch2/tech_diagram.png">    </p:cNvPr>
+          <p:cNvPr id="5" name="Image 0" descr="/home/claude/pitch2/tech_diagram.png"/>
           <p:cNvPicPr>
             <a:picLocks noChangeAspect="1"/>
           </p:cNvPicPr>
@@ -2232,13 +2194,12 @@
             <a:avLst/>
           </a:prstGeom>
           <a:noFill/>
-          <a:ln/>
         </p:spPr>
         <p:txBody>
           <a:bodyPr wrap="square" rtlCol="0" anchor="ctr"/>
           <a:lstStyle/>
           <a:p>
-            <a:pPr algn="l" indent="0" marL="0">
+            <a:pPr marL="0" indent="0" algn="l">
               <a:buNone/>
             </a:pPr>
             <a:r>
@@ -2246,9 +2207,9 @@
                 <a:solidFill>
                   <a:srgbClr val="1F3350"/>
                 </a:solidFill>
-                <a:latin typeface="Times New Roman" pitchFamily="34" charset="0"/>
-                <a:ea typeface="Times New Roman" pitchFamily="34" charset="-122"/>
-                <a:cs typeface="Times New Roman" pitchFamily="34" charset="-120"/>
+                <a:latin typeface="Times New Roman" panose="02020603050405020304" pitchFamily="34" charset="0"/>
+                <a:ea typeface="Times New Roman" panose="02020603050405020304" pitchFamily="34" charset="-122"/>
+                <a:cs typeface="Times New Roman" panose="02020603050405020304" pitchFamily="34" charset="-120"/>
               </a:rPr>
               <a:t>Dynamic Fire Evacuation Router</a:t>
             </a:r>
@@ -2271,13 +2232,12 @@
             <a:avLst/>
           </a:prstGeom>
           <a:noFill/>
-          <a:ln/>
         </p:spPr>
         <p:txBody>
           <a:bodyPr wrap="square" rtlCol="0" anchor="ctr"/>
           <a:lstStyle/>
           <a:p>
-            <a:pPr algn="r" indent="0" marL="0">
+            <a:pPr marL="0" indent="0" algn="r">
               <a:buNone/>
             </a:pPr>
             <a:r>
@@ -2285,9 +2245,9 @@
                 <a:solidFill>
                   <a:srgbClr val="1F3350"/>
                 </a:solidFill>
-                <a:latin typeface="Times New Roman" pitchFamily="34" charset="0"/>
-                <a:ea typeface="Times New Roman" pitchFamily="34" charset="-122"/>
-                <a:cs typeface="Times New Roman" pitchFamily="34" charset="-120"/>
+                <a:latin typeface="Times New Roman" panose="02020603050405020304" pitchFamily="34" charset="0"/>
+                <a:ea typeface="Times New Roman" panose="02020603050405020304" pitchFamily="34" charset="-122"/>
+                <a:cs typeface="Times New Roman" panose="02020603050405020304" pitchFamily="34" charset="-120"/>
               </a:rPr>
               <a:t>3</a:t>
             </a:r>
@@ -2305,12 +2265,13 @@
 
 <file path=ppt/slides/slide4.xml><?xml version="1.0" encoding="utf-8"?>
 <p:sld xmlns:a="http://schemas.openxmlformats.org/drawingml/2006/main" xmlns:r="http://schemas.openxmlformats.org/officeDocument/2006/relationships" xmlns:p="http://schemas.openxmlformats.org/presentationml/2006/main">
-  <p:cSld name="Slide 4">
+  <p:cSld>
     <p:bg>
       <p:bgPr>
         <a:solidFill>
           <a:srgbClr val="FFFFFF"/>
         </a:solidFill>
+        <a:effectLst/>
       </p:bgPr>
     </p:bg>
     <p:spTree>
@@ -2342,13 +2303,12 @@
             <a:avLst/>
           </a:prstGeom>
           <a:noFill/>
-          <a:ln/>
         </p:spPr>
         <p:txBody>
           <a:bodyPr wrap="square" rtlCol="0" anchor="ctr"/>
           <a:lstStyle/>
           <a:p>
-            <a:pPr algn="l" indent="0" marL="0">
+            <a:pPr marL="0" indent="0" algn="l">
               <a:buNone/>
             </a:pPr>
             <a:r>
@@ -2356,9 +2316,9 @@
                 <a:solidFill>
                   <a:srgbClr val="1F3350"/>
                 </a:solidFill>
-                <a:latin typeface="Times New Roman" pitchFamily="34" charset="0"/>
-                <a:ea typeface="Times New Roman" pitchFamily="34" charset="-122"/>
-                <a:cs typeface="Times New Roman" pitchFamily="34" charset="-120"/>
+                <a:latin typeface="Times New Roman" panose="02020603050405020304" pitchFamily="34" charset="0"/>
+                <a:ea typeface="Times New Roman" panose="02020603050405020304" pitchFamily="34" charset="-122"/>
+                <a:cs typeface="Times New Roman" panose="02020603050405020304" pitchFamily="34" charset="-120"/>
               </a:rPr>
               <a:t>Feasibility and viability</a:t>
             </a:r>
@@ -2381,13 +2341,12 @@
             <a:avLst/>
           </a:prstGeom>
           <a:noFill/>
-          <a:ln/>
         </p:spPr>
         <p:txBody>
           <a:bodyPr wrap="square" rtlCol="0" anchor="ctr"/>
           <a:lstStyle/>
           <a:p>
-            <a:pPr indent="0" marL="0">
+            <a:pPr marL="0" indent="0">
               <a:buNone/>
             </a:pPr>
             <a:r>
@@ -2395,9 +2354,9 @@
                 <a:solidFill>
                   <a:srgbClr val="000000"/>
                 </a:solidFill>
-                <a:latin typeface="Times New Roman" pitchFamily="34" charset="0"/>
-                <a:ea typeface="Times New Roman" pitchFamily="34" charset="-122"/>
-                <a:cs typeface="Times New Roman" pitchFamily="34" charset="-120"/>
+                <a:latin typeface="Times New Roman" panose="02020603050405020304" pitchFamily="34" charset="0"/>
+                <a:ea typeface="Times New Roman" panose="02020603050405020304" pitchFamily="34" charset="-122"/>
+                <a:cs typeface="Times New Roman" panose="02020603050405020304" pitchFamily="34" charset="-120"/>
               </a:rPr>
               <a:t>Fully working software prototype validated end-to-end across 36 zones.</a:t>
             </a:r>
@@ -2411,17 +2370,11 @@
           <p:cNvGraphicFramePr>
             <a:graphicFrameLocks noGrp="1"/>
           </p:cNvGraphicFramePr>
-          <p:nvPr>
-            <p:extLst>
-              <p:ext uri="{D42A27DB-BD31-4B8C-83A1-F6EECF244321}">
-                <p14:modId xmlns:p14="http://schemas.microsoft.com/office/powerpoint/2010/main" val="1579011935"/>
-              </p:ext>
-            </p:extLst>
-          </p:nvPr>
+          <p:nvPr/>
         </p:nvGraphicFramePr>
         <p:xfrm>
           <a:off x="548640" y="1874520"/>
-          <a:ext cx="11094415" cy="2103120"/>
+          <a:ext cx="11435715" cy="2103120"/>
         </p:xfrm>
         <a:graphic>
           <a:graphicData uri="http://schemas.openxmlformats.org/drawingml/2006/table">
@@ -2430,7 +2383,7 @@
               <a:tblGrid>
                 <a:gridCol w="2194560"/>
                 <a:gridCol w="4816145"/>
-                <a:gridCol w="4816145"/>
+                <a:gridCol w="4425315"/>
               </a:tblGrid>
               <a:tr h="701040">
                 <a:tc>
@@ -2438,7 +2391,7 @@
                     <a:bodyPr/>
                     <a:lstStyle/>
                     <a:p>
-                      <a:pPr indent="0" marL="0">
+                      <a:pPr marL="0" indent="0">
                         <a:buNone/>
                       </a:pPr>
                       <a:r>
@@ -2446,20 +2399,20 @@
                           <a:solidFill>
                             <a:srgbClr val="1F3350"/>
                           </a:solidFill>
-                          <a:latin typeface="Times New Roman" pitchFamily="34" charset="0"/>
-                          <a:ea typeface="Times New Roman" pitchFamily="34" charset="-122"/>
-                          <a:cs typeface="Times New Roman" pitchFamily="34" charset="-120"/>
+                          <a:latin typeface="Times New Roman" panose="02020603050405020304" pitchFamily="34" charset="0"/>
+                          <a:ea typeface="Times New Roman" panose="02020603050405020304" pitchFamily="34" charset="-122"/>
+                          <a:cs typeface="Times New Roman" panose="02020603050405020304" pitchFamily="34" charset="-120"/>
                         </a:rPr>
                         <a:t>Issue</a:t>
                       </a:r>
                       <a:endParaRPr lang="en-US" sz="1400" dirty="0">
-                        <a:latin typeface="Times New Roman" charset="0"/>
-                        <a:ea typeface="Times New Roman" charset="0"/>
-                        <a:cs typeface="Times New Roman" charset="0"/>
+                        <a:latin typeface="Times New Roman" panose="02020603050405020304" pitchFamily="34" charset="0"/>
+                        <a:ea typeface="Times New Roman" panose="02020603050405020304" pitchFamily="34" charset="0"/>
+                        <a:cs typeface="Times New Roman" panose="02020603050405020304" pitchFamily="34" charset="0"/>
                       </a:endParaRPr>
                     </a:p>
                   </a:txBody>
-                  <a:tcPr marL="91440" marR="91440" marT="45720" marB="45720" anchor="ctr">
+                  <a:tcPr anchor="ctr">
                     <a:lnL w="9525" cap="flat" cmpd="sng" algn="ctr">
                       <a:solidFill>
                         <a:srgbClr val="888888"/>
@@ -2506,7 +2459,7 @@
                     <a:bodyPr/>
                     <a:lstStyle/>
                     <a:p>
-                      <a:pPr indent="0" marL="0">
+                      <a:pPr marL="0" indent="0">
                         <a:buNone/>
                       </a:pPr>
                       <a:r>
@@ -2514,20 +2467,20 @@
                           <a:solidFill>
                             <a:srgbClr val="1F3350"/>
                           </a:solidFill>
-                          <a:latin typeface="Times New Roman" pitchFamily="34" charset="0"/>
-                          <a:ea typeface="Times New Roman" pitchFamily="34" charset="-122"/>
-                          <a:cs typeface="Times New Roman" pitchFamily="34" charset="-120"/>
+                          <a:latin typeface="Times New Roman" panose="02020603050405020304" pitchFamily="34" charset="0"/>
+                          <a:ea typeface="Times New Roman" panose="02020603050405020304" pitchFamily="34" charset="-122"/>
+                          <a:cs typeface="Times New Roman" panose="02020603050405020304" pitchFamily="34" charset="-120"/>
                         </a:rPr>
                         <a:t>Root cause</a:t>
                       </a:r>
                       <a:endParaRPr lang="en-US" sz="1400" dirty="0">
-                        <a:latin typeface="Times New Roman" charset="0"/>
-                        <a:ea typeface="Times New Roman" charset="0"/>
-                        <a:cs typeface="Times New Roman" charset="0"/>
+                        <a:latin typeface="Times New Roman" panose="02020603050405020304" pitchFamily="34" charset="0"/>
+                        <a:ea typeface="Times New Roman" panose="02020603050405020304" pitchFamily="34" charset="0"/>
+                        <a:cs typeface="Times New Roman" panose="02020603050405020304" pitchFamily="34" charset="0"/>
                       </a:endParaRPr>
                     </a:p>
                   </a:txBody>
-                  <a:tcPr marL="91440" marR="91440" marT="45720" marB="45720" anchor="ctr">
+                  <a:tcPr anchor="ctr">
                     <a:lnL w="9525" cap="flat" cmpd="sng" algn="ctr">
                       <a:solidFill>
                         <a:srgbClr val="888888"/>
@@ -2574,7 +2527,7 @@
                     <a:bodyPr/>
                     <a:lstStyle/>
                     <a:p>
-                      <a:pPr indent="0" marL="0">
+                      <a:pPr marL="0" indent="0">
                         <a:buNone/>
                       </a:pPr>
                       <a:r>
@@ -2582,20 +2535,20 @@
                           <a:solidFill>
                             <a:srgbClr val="1F3350"/>
                           </a:solidFill>
-                          <a:latin typeface="Times New Roman" pitchFamily="34" charset="0"/>
-                          <a:ea typeface="Times New Roman" pitchFamily="34" charset="-122"/>
-                          <a:cs typeface="Times New Roman" pitchFamily="34" charset="-120"/>
+                          <a:latin typeface="Times New Roman" panose="02020603050405020304" pitchFamily="34" charset="0"/>
+                          <a:ea typeface="Times New Roman" panose="02020603050405020304" pitchFamily="34" charset="-122"/>
+                          <a:cs typeface="Times New Roman" panose="02020603050405020304" pitchFamily="34" charset="-120"/>
                         </a:rPr>
                         <a:t>Resolution</a:t>
                       </a:r>
                       <a:endParaRPr lang="en-US" sz="1400" dirty="0">
-                        <a:latin typeface="Times New Roman" charset="0"/>
-                        <a:ea typeface="Times New Roman" charset="0"/>
-                        <a:cs typeface="Times New Roman" charset="0"/>
+                        <a:latin typeface="Times New Roman" panose="02020603050405020304" pitchFamily="34" charset="0"/>
+                        <a:ea typeface="Times New Roman" panose="02020603050405020304" pitchFamily="34" charset="0"/>
+                        <a:cs typeface="Times New Roman" panose="02020603050405020304" pitchFamily="34" charset="0"/>
                       </a:endParaRPr>
                     </a:p>
                   </a:txBody>
-                  <a:tcPr marL="91440" marR="91440" marT="45720" marB="45720" anchor="ctr">
+                  <a:tcPr anchor="ctr">
                     <a:lnL w="9525" cap="flat" cmpd="sng" algn="ctr">
                       <a:solidFill>
                         <a:srgbClr val="888888"/>
@@ -2644,7 +2597,7 @@
                     <a:bodyPr/>
                     <a:lstStyle/>
                     <a:p>
-                      <a:pPr indent="0" marL="0">
+                      <a:pPr marL="0" indent="0">
                         <a:buNone/>
                       </a:pPr>
                       <a:r>
@@ -2652,20 +2605,20 @@
                           <a:solidFill>
                             <a:srgbClr val="000000"/>
                           </a:solidFill>
-                          <a:latin typeface="Times New Roman" pitchFamily="34" charset="0"/>
-                          <a:ea typeface="Times New Roman" pitchFamily="34" charset="-122"/>
-                          <a:cs typeface="Times New Roman" pitchFamily="34" charset="-120"/>
+                          <a:latin typeface="Times New Roman" panose="02020603050405020304" pitchFamily="34" charset="0"/>
+                          <a:ea typeface="Times New Roman" panose="02020603050405020304" pitchFamily="34" charset="-122"/>
+                          <a:cs typeface="Times New Roman" panose="02020603050405020304" pitchFamily="34" charset="-120"/>
                         </a:rPr>
                         <a:t>Redundant</a:t>
                       </a:r>
                       <a:endParaRPr lang="en-US" sz="1400" dirty="0">
-                        <a:latin typeface="Times New Roman" charset="0"/>
-                        <a:ea typeface="Times New Roman" charset="0"/>
-                        <a:cs typeface="Times New Roman" charset="0"/>
+                        <a:latin typeface="Times New Roman" panose="02020603050405020304" pitchFamily="34" charset="0"/>
+                        <a:ea typeface="Times New Roman" panose="02020603050405020304" pitchFamily="34" charset="0"/>
+                        <a:cs typeface="Times New Roman" panose="02020603050405020304" pitchFamily="34" charset="0"/>
                       </a:endParaRPr>
                     </a:p>
                     <a:p>
-                      <a:pPr indent="0" marL="0">
+                      <a:pPr marL="0" indent="0">
                         <a:buNone/>
                       </a:pPr>
                       <a:r>
@@ -2673,20 +2626,20 @@
                           <a:solidFill>
                             <a:srgbClr val="000000"/>
                           </a:solidFill>
-                          <a:latin typeface="Times New Roman" pitchFamily="34" charset="0"/>
-                          <a:ea typeface="Times New Roman" pitchFamily="34" charset="-122"/>
-                          <a:cs typeface="Times New Roman" pitchFamily="34" charset="-120"/>
+                          <a:latin typeface="Times New Roman" panose="02020603050405020304" pitchFamily="34" charset="0"/>
+                          <a:ea typeface="Times New Roman" panose="02020603050405020304" pitchFamily="34" charset="-122"/>
+                          <a:cs typeface="Times New Roman" panose="02020603050405020304" pitchFamily="34" charset="-120"/>
                         </a:rPr>
                         <a:t>recomputation</a:t>
                       </a:r>
                       <a:endParaRPr lang="en-US" sz="1400" dirty="0">
-                        <a:latin typeface="Times New Roman" charset="0"/>
-                        <a:ea typeface="Times New Roman" charset="0"/>
-                        <a:cs typeface="Times New Roman" charset="0"/>
+                        <a:latin typeface="Times New Roman" panose="02020603050405020304" pitchFamily="34" charset="0"/>
+                        <a:ea typeface="Times New Roman" panose="02020603050405020304" pitchFamily="34" charset="0"/>
+                        <a:cs typeface="Times New Roman" panose="02020603050405020304" pitchFamily="34" charset="0"/>
                       </a:endParaRPr>
                     </a:p>
                   </a:txBody>
-                  <a:tcPr marL="91440" marR="91440" marT="45720" marB="45720" anchor="ctr">
+                  <a:tcPr anchor="ctr">
                     <a:lnL w="9525" cap="flat" cmpd="sng" algn="ctr">
                       <a:solidFill>
                         <a:srgbClr val="888888"/>
@@ -2730,7 +2683,7 @@
                     <a:bodyPr/>
                     <a:lstStyle/>
                     <a:p>
-                      <a:pPr indent="0" marL="0">
+                      <a:pPr marL="0" indent="0">
                         <a:buNone/>
                       </a:pPr>
                       <a:r>
@@ -2738,20 +2691,20 @@
                           <a:solidFill>
                             <a:srgbClr val="000000"/>
                           </a:solidFill>
-                          <a:latin typeface="Times New Roman" pitchFamily="34" charset="0"/>
-                          <a:ea typeface="Times New Roman" pitchFamily="34" charset="-122"/>
-                          <a:cs typeface="Times New Roman" pitchFamily="34" charset="-120"/>
+                          <a:latin typeface="Times New Roman" panose="02020603050405020304" pitchFamily="34" charset="0"/>
+                          <a:ea typeface="Times New Roman" panose="02020603050405020304" pitchFamily="34" charset="-122"/>
+                          <a:cs typeface="Times New Roman" panose="02020603050405020304" pitchFamily="34" charset="-120"/>
                         </a:rPr>
                         <a:t>Each of 36 nodes independently re-ran Dijkstra per update</a:t>
                       </a:r>
                       <a:endParaRPr lang="en-US" sz="1400" dirty="0">
-                        <a:latin typeface="Times New Roman" charset="0"/>
-                        <a:ea typeface="Times New Roman" charset="0"/>
-                        <a:cs typeface="Times New Roman" charset="0"/>
+                        <a:latin typeface="Times New Roman" panose="02020603050405020304" pitchFamily="34" charset="0"/>
+                        <a:ea typeface="Times New Roman" panose="02020603050405020304" pitchFamily="34" charset="0"/>
+                        <a:cs typeface="Times New Roman" panose="02020603050405020304" pitchFamily="34" charset="0"/>
                       </a:endParaRPr>
                     </a:p>
                   </a:txBody>
-                  <a:tcPr marL="91440" marR="91440" marT="45720" marB="45720" anchor="ctr">
+                  <a:tcPr anchor="ctr">
                     <a:lnL w="9525" cap="flat" cmpd="sng" algn="ctr">
                       <a:solidFill>
                         <a:srgbClr val="888888"/>
@@ -2795,7 +2748,7 @@
                     <a:bodyPr/>
                     <a:lstStyle/>
                     <a:p>
-                      <a:pPr indent="0" marL="0">
+                      <a:pPr marL="0" indent="0">
                         <a:buNone/>
                       </a:pPr>
                       <a:r>
@@ -2803,20 +2756,20 @@
                           <a:solidFill>
                             <a:srgbClr val="000000"/>
                           </a:solidFill>
-                          <a:latin typeface="Times New Roman" pitchFamily="34" charset="0"/>
-                          <a:ea typeface="Times New Roman" pitchFamily="34" charset="-122"/>
-                          <a:cs typeface="Times New Roman" pitchFamily="34" charset="-120"/>
+                          <a:latin typeface="Times New Roman" panose="02020603050405020304" pitchFamily="34" charset="0"/>
+                          <a:ea typeface="Times New Roman" panose="02020603050405020304" pitchFamily="34" charset="-122"/>
+                          <a:cs typeface="Times New Roman" panose="02020603050405020304" pitchFamily="34" charset="-120"/>
                         </a:rPr>
                         <a:t>One centralized coordinator computes and broadcasts routes</a:t>
                       </a:r>
                       <a:endParaRPr lang="en-US" sz="1400" dirty="0">
-                        <a:latin typeface="Times New Roman" charset="0"/>
-                        <a:ea typeface="Times New Roman" charset="0"/>
-                        <a:cs typeface="Times New Roman" charset="0"/>
+                        <a:latin typeface="Times New Roman" panose="02020603050405020304" pitchFamily="34" charset="0"/>
+                        <a:ea typeface="Times New Roman" panose="02020603050405020304" pitchFamily="34" charset="0"/>
+                        <a:cs typeface="Times New Roman" panose="02020603050405020304" pitchFamily="34" charset="0"/>
                       </a:endParaRPr>
                     </a:p>
                   </a:txBody>
-                  <a:tcPr marL="91440" marR="91440" marT="45720" marB="45720" anchor="ctr">
+                  <a:tcPr anchor="ctr">
                     <a:lnL w="9525" cap="flat" cmpd="sng" algn="ctr">
                       <a:solidFill>
                         <a:srgbClr val="888888"/>
@@ -2862,7 +2815,7 @@
                     <a:bodyPr/>
                     <a:lstStyle/>
                     <a:p>
-                      <a:pPr indent="0" marL="0">
+                      <a:pPr marL="0" indent="0">
                         <a:buNone/>
                       </a:pPr>
                       <a:r>
@@ -2870,20 +2823,20 @@
                           <a:solidFill>
                             <a:srgbClr val="000000"/>
                           </a:solidFill>
-                          <a:latin typeface="Times New Roman" pitchFamily="34" charset="0"/>
-                          <a:ea typeface="Times New Roman" pitchFamily="34" charset="-122"/>
-                          <a:cs typeface="Times New Roman" pitchFamily="34" charset="-120"/>
+                          <a:latin typeface="Times New Roman" panose="02020603050405020304" pitchFamily="34" charset="0"/>
+                          <a:ea typeface="Times New Roman" panose="02020603050405020304" pitchFamily="34" charset="-122"/>
+                          <a:cs typeface="Times New Roman" panose="02020603050405020304" pitchFamily="34" charset="-120"/>
                         </a:rPr>
                         <a:t>MQTT publish</a:t>
                       </a:r>
                       <a:endParaRPr lang="en-US" sz="1400" dirty="0">
-                        <a:latin typeface="Times New Roman" charset="0"/>
-                        <a:ea typeface="Times New Roman" charset="0"/>
-                        <a:cs typeface="Times New Roman" charset="0"/>
+                        <a:latin typeface="Times New Roman" panose="02020603050405020304" pitchFamily="34" charset="0"/>
+                        <a:ea typeface="Times New Roman" panose="02020603050405020304" pitchFamily="34" charset="0"/>
+                        <a:cs typeface="Times New Roman" panose="02020603050405020304" pitchFamily="34" charset="0"/>
                       </a:endParaRPr>
                     </a:p>
                     <a:p>
-                      <a:pPr indent="0" marL="0">
+                      <a:pPr marL="0" indent="0">
                         <a:buNone/>
                       </a:pPr>
                       <a:r>
@@ -2891,20 +2844,20 @@
                           <a:solidFill>
                             <a:srgbClr val="000000"/>
                           </a:solidFill>
-                          <a:latin typeface="Times New Roman" pitchFamily="34" charset="0"/>
-                          <a:ea typeface="Times New Roman" pitchFamily="34" charset="-122"/>
-                          <a:cs typeface="Times New Roman" pitchFamily="34" charset="-120"/>
+                          <a:latin typeface="Times New Roman" panose="02020603050405020304" pitchFamily="34" charset="0"/>
+                          <a:ea typeface="Times New Roman" panose="02020603050405020304" pitchFamily="34" charset="-122"/>
+                          <a:cs typeface="Times New Roman" panose="02020603050405020304" pitchFamily="34" charset="-120"/>
                         </a:rPr>
                         <a:t>volume growth</a:t>
                       </a:r>
                       <a:endParaRPr lang="en-US" sz="1400" dirty="0">
-                        <a:latin typeface="Times New Roman" charset="0"/>
-                        <a:ea typeface="Times New Roman" charset="0"/>
-                        <a:cs typeface="Times New Roman" charset="0"/>
+                        <a:latin typeface="Times New Roman" panose="02020603050405020304" pitchFamily="34" charset="0"/>
+                        <a:ea typeface="Times New Roman" panose="02020603050405020304" pitchFamily="34" charset="0"/>
+                        <a:cs typeface="Times New Roman" panose="02020603050405020304" pitchFamily="34" charset="0"/>
                       </a:endParaRPr>
                     </a:p>
                   </a:txBody>
-                  <a:tcPr marL="91440" marR="91440" marT="45720" marB="45720" anchor="ctr">
+                  <a:tcPr anchor="ctr">
                     <a:lnL w="9525" cap="flat" cmpd="sng" algn="ctr">
                       <a:solidFill>
                         <a:srgbClr val="888888"/>
@@ -2948,7 +2901,7 @@
                     <a:bodyPr/>
                     <a:lstStyle/>
                     <a:p>
-                      <a:pPr indent="0" marL="0">
+                      <a:pPr marL="0" indent="0">
                         <a:buNone/>
                       </a:pPr>
                       <a:r>
@@ -2956,20 +2909,20 @@
                           <a:solidFill>
                             <a:srgbClr val="000000"/>
                           </a:solidFill>
-                          <a:latin typeface="Times New Roman" pitchFamily="34" charset="0"/>
-                          <a:ea typeface="Times New Roman" pitchFamily="34" charset="-122"/>
-                          <a:cs typeface="Times New Roman" pitchFamily="34" charset="-120"/>
+                          <a:latin typeface="Times New Roman" panose="02020603050405020304" pitchFamily="34" charset="0"/>
+                          <a:ea typeface="Times New Roman" panose="02020603050405020304" pitchFamily="34" charset="-122"/>
+                          <a:cs typeface="Times New Roman" panose="02020603050405020304" pitchFamily="34" charset="-120"/>
                         </a:rPr>
                         <a:t>Every node republished LED state on every broadcast</a:t>
                       </a:r>
                       <a:endParaRPr lang="en-US" sz="1400" dirty="0">
-                        <a:latin typeface="Times New Roman" charset="0"/>
-                        <a:ea typeface="Times New Roman" charset="0"/>
-                        <a:cs typeface="Times New Roman" charset="0"/>
+                        <a:latin typeface="Times New Roman" panose="02020603050405020304" pitchFamily="34" charset="0"/>
+                        <a:ea typeface="Times New Roman" panose="02020603050405020304" pitchFamily="34" charset="0"/>
+                        <a:cs typeface="Times New Roman" panose="02020603050405020304" pitchFamily="34" charset="0"/>
                       </a:endParaRPr>
                     </a:p>
                   </a:txBody>
-                  <a:tcPr marL="91440" marR="91440" marT="45720" marB="45720" anchor="ctr">
+                  <a:tcPr anchor="ctr">
                     <a:lnL w="9525" cap="flat" cmpd="sng" algn="ctr">
                       <a:solidFill>
                         <a:srgbClr val="888888"/>
@@ -3013,7 +2966,7 @@
                     <a:bodyPr/>
                     <a:lstStyle/>
                     <a:p>
-                      <a:pPr indent="0" marL="0">
+                      <a:pPr marL="0" indent="0">
                         <a:buNone/>
                       </a:pPr>
                       <a:r>
@@ -3021,20 +2974,20 @@
                           <a:solidFill>
                             <a:srgbClr val="000000"/>
                           </a:solidFill>
-                          <a:latin typeface="Times New Roman" pitchFamily="34" charset="0"/>
-                          <a:ea typeface="Times New Roman" pitchFamily="34" charset="-122"/>
-                          <a:cs typeface="Times New Roman" pitchFamily="34" charset="-120"/>
+                          <a:latin typeface="Times New Roman" panose="02020603050405020304" pitchFamily="34" charset="0"/>
+                          <a:ea typeface="Times New Roman" panose="02020603050405020304" pitchFamily="34" charset="-122"/>
+                          <a:cs typeface="Times New Roman" panose="02020603050405020304" pitchFamily="34" charset="-120"/>
                         </a:rPr>
                         <a:t>Publish only on real state change, plus keepalive</a:t>
                       </a:r>
                       <a:endParaRPr lang="en-US" sz="1400" dirty="0">
-                        <a:latin typeface="Times New Roman" charset="0"/>
-                        <a:ea typeface="Times New Roman" charset="0"/>
-                        <a:cs typeface="Times New Roman" charset="0"/>
+                        <a:latin typeface="Times New Roman" panose="02020603050405020304" pitchFamily="34" charset="0"/>
+                        <a:ea typeface="Times New Roman" panose="02020603050405020304" pitchFamily="34" charset="0"/>
+                        <a:cs typeface="Times New Roman" panose="02020603050405020304" pitchFamily="34" charset="0"/>
                       </a:endParaRPr>
                     </a:p>
                   </a:txBody>
-                  <a:tcPr marL="91440" marR="91440" marT="45720" marB="45720" anchor="ctr">
+                  <a:tcPr anchor="ctr">
                     <a:lnL w="9525" cap="flat" cmpd="sng" algn="ctr">
                       <a:solidFill>
                         <a:srgbClr val="888888"/>
@@ -3080,7 +3033,7 @@
       </p:graphicFrame>
       <p:sp>
         <p:nvSpPr>
-          <p:cNvPr id="5" name="Text 2"/>
+          <p:cNvPr id="4" name="Text 2"/>
           <p:cNvSpPr/>
           <p:nvPr/>
         </p:nvSpPr>
@@ -3093,13 +3046,12 @@
             <a:avLst/>
           </a:prstGeom>
           <a:noFill/>
-          <a:ln/>
         </p:spPr>
         <p:txBody>
           <a:bodyPr wrap="square" rtlCol="0" anchor="ctr"/>
           <a:lstStyle/>
           <a:p>
-            <a:pPr indent="0" marL="0">
+            <a:pPr marL="0" indent="0">
               <a:buNone/>
             </a:pPr>
             <a:r>
@@ -3107,9 +3059,9 @@
                 <a:solidFill>
                   <a:srgbClr val="1F3350"/>
                 </a:solidFill>
-                <a:latin typeface="Times New Roman" pitchFamily="34" charset="0"/>
-                <a:ea typeface="Times New Roman" pitchFamily="34" charset="-122"/>
-                <a:cs typeface="Times New Roman" pitchFamily="34" charset="-120"/>
+                <a:latin typeface="Times New Roman" panose="02020603050405020304" pitchFamily="34" charset="0"/>
+                <a:ea typeface="Times New Roman" panose="02020603050405020304" pitchFamily="34" charset="-122"/>
+                <a:cs typeface="Times New Roman" panose="02020603050405020304" pitchFamily="34" charset="-120"/>
               </a:rPr>
               <a:t>Result: typical recompute latency of 20–130 ms, within the 300 ms budget.</a:t>
             </a:r>
@@ -3132,13 +3084,12 @@
             <a:avLst/>
           </a:prstGeom>
           <a:noFill/>
-          <a:ln/>
         </p:spPr>
         <p:txBody>
           <a:bodyPr wrap="square" rtlCol="0" anchor="ctr"/>
           <a:lstStyle/>
           <a:p>
-            <a:pPr algn="l" indent="0" marL="0">
+            <a:pPr marL="0" indent="0" algn="l">
               <a:buNone/>
             </a:pPr>
             <a:r>
@@ -3146,9 +3097,9 @@
                 <a:solidFill>
                   <a:srgbClr val="1F3350"/>
                 </a:solidFill>
-                <a:latin typeface="Times New Roman" pitchFamily="34" charset="0"/>
-                <a:ea typeface="Times New Roman" pitchFamily="34" charset="-122"/>
-                <a:cs typeface="Times New Roman" pitchFamily="34" charset="-120"/>
+                <a:latin typeface="Times New Roman" panose="02020603050405020304" pitchFamily="34" charset="0"/>
+                <a:ea typeface="Times New Roman" panose="02020603050405020304" pitchFamily="34" charset="-122"/>
+                <a:cs typeface="Times New Roman" panose="02020603050405020304" pitchFamily="34" charset="-120"/>
               </a:rPr>
               <a:t>Dynamic Fire Evacuation Router</a:t>
             </a:r>
@@ -3171,13 +3122,12 @@
             <a:avLst/>
           </a:prstGeom>
           <a:noFill/>
-          <a:ln/>
         </p:spPr>
         <p:txBody>
           <a:bodyPr wrap="square" rtlCol="0" anchor="ctr"/>
           <a:lstStyle/>
           <a:p>
-            <a:pPr algn="r" indent="0" marL="0">
+            <a:pPr marL="0" indent="0" algn="r">
               <a:buNone/>
             </a:pPr>
             <a:r>
@@ -3185,9 +3135,9 @@
                 <a:solidFill>
                   <a:srgbClr val="1F3350"/>
                 </a:solidFill>
-                <a:latin typeface="Times New Roman" pitchFamily="34" charset="0"/>
-                <a:ea typeface="Times New Roman" pitchFamily="34" charset="-122"/>
-                <a:cs typeface="Times New Roman" pitchFamily="34" charset="-120"/>
+                <a:latin typeface="Times New Roman" panose="02020603050405020304" pitchFamily="34" charset="0"/>
+                <a:ea typeface="Times New Roman" panose="02020603050405020304" pitchFamily="34" charset="-122"/>
+                <a:cs typeface="Times New Roman" panose="02020603050405020304" pitchFamily="34" charset="-120"/>
               </a:rPr>
               <a:t>4</a:t>
             </a:r>
@@ -3205,12 +3155,13 @@
 
 <file path=ppt/slides/slide5.xml><?xml version="1.0" encoding="utf-8"?>
 <p:sld xmlns:a="http://schemas.openxmlformats.org/drawingml/2006/main" xmlns:r="http://schemas.openxmlformats.org/officeDocument/2006/relationships" xmlns:p="http://schemas.openxmlformats.org/presentationml/2006/main">
-  <p:cSld name="Slide 5">
+  <p:cSld>
     <p:bg>
       <p:bgPr>
         <a:solidFill>
           <a:srgbClr val="FFFFFF"/>
         </a:solidFill>
+        <a:effectLst/>
       </p:bgPr>
     </p:bg>
     <p:spTree>
@@ -3242,13 +3193,12 @@
             <a:avLst/>
           </a:prstGeom>
           <a:noFill/>
-          <a:ln/>
         </p:spPr>
         <p:txBody>
           <a:bodyPr wrap="square" rtlCol="0" anchor="ctr"/>
           <a:lstStyle/>
           <a:p>
-            <a:pPr algn="l" indent="0" marL="0">
+            <a:pPr marL="0" indent="0" algn="l">
               <a:buNone/>
             </a:pPr>
             <a:r>
@@ -3256,9 +3206,9 @@
                 <a:solidFill>
                   <a:srgbClr val="1F3350"/>
                 </a:solidFill>
-                <a:latin typeface="Times New Roman" pitchFamily="34" charset="0"/>
-                <a:ea typeface="Times New Roman" pitchFamily="34" charset="-122"/>
-                <a:cs typeface="Times New Roman" pitchFamily="34" charset="-120"/>
+                <a:latin typeface="Times New Roman" panose="02020603050405020304" pitchFamily="34" charset="0"/>
+                <a:ea typeface="Times New Roman" panose="02020603050405020304" pitchFamily="34" charset="-122"/>
+                <a:cs typeface="Times New Roman" panose="02020603050405020304" pitchFamily="34" charset="-120"/>
               </a:rPr>
               <a:t>Artifacts</a:t>
             </a:r>
@@ -3281,7 +3231,6 @@
             <a:avLst/>
           </a:prstGeom>
           <a:noFill/>
-          <a:ln/>
         </p:spPr>
         <p:txBody>
           <a:bodyPr wrap="square" rtlCol="0" anchor="ctr"/>
@@ -3299,9 +3248,9 @@
                 <a:solidFill>
                   <a:srgbClr val="000000"/>
                 </a:solidFill>
-                <a:latin typeface="Times New Roman" pitchFamily="34" charset="0"/>
-                <a:ea typeface="Times New Roman" pitchFamily="34" charset="-122"/>
-                <a:cs typeface="Times New Roman" pitchFamily="34" charset="-120"/>
+                <a:latin typeface="Times New Roman" panose="02020603050405020304" pitchFamily="34" charset="0"/>
+                <a:ea typeface="Times New Roman" panose="02020603050405020304" pitchFamily="34" charset="-122"/>
+                <a:cs typeface="Times New Roman" panose="02020603050405020304" pitchFamily="34" charset="-120"/>
               </a:rPr>
               <a:t>Source code: full repository publicly available at github.com/kishaunjith-S/fire-evac-router</a:t>
             </a:r>
@@ -3311,7 +3260,7 @@
       </p:sp>
       <p:pic>
         <p:nvPicPr>
-          <p:cNvPr id="4" name="Image 0" descr="/home/claude/pitch2/injector_shot.jpg">    </p:cNvPr>
+          <p:cNvPr id="4" name="Image 0" descr="/home/claude/pitch2/injector_shot.jpg"/>
           <p:cNvPicPr>
             <a:picLocks noChangeAspect="1"/>
           </p:cNvPicPr>
@@ -3348,13 +3297,12 @@
             <a:avLst/>
           </a:prstGeom>
           <a:noFill/>
-          <a:ln/>
         </p:spPr>
         <p:txBody>
           <a:bodyPr wrap="square" rtlCol="0" anchor="ctr"/>
           <a:lstStyle/>
           <a:p>
-            <a:pPr algn="ctr" indent="0" marL="0">
+            <a:pPr marL="0" indent="0" algn="ctr">
               <a:buNone/>
             </a:pPr>
             <a:r>
@@ -3362,9 +3310,9 @@
                 <a:solidFill>
                   <a:srgbClr val="1F3350"/>
                 </a:solidFill>
-                <a:latin typeface="Times New Roman" pitchFamily="34" charset="0"/>
-                <a:ea typeface="Times New Roman" pitchFamily="34" charset="-122"/>
-                <a:cs typeface="Times New Roman" pitchFamily="34" charset="-120"/>
+                <a:latin typeface="Times New Roman" panose="02020603050405020304" pitchFamily="34" charset="0"/>
+                <a:ea typeface="Times New Roman" panose="02020603050405020304" pitchFamily="34" charset="-122"/>
+                <a:cs typeface="Times New Roman" panose="02020603050405020304" pitchFamily="34" charset="-120"/>
               </a:rPr>
               <a:t>Figure 2. Control-panel simulator</a:t>
             </a:r>
@@ -3374,7 +3322,7 @@
       </p:sp>
       <p:pic>
         <p:nvPicPr>
-          <p:cNvPr id="6" name="Image 1" descr="/home/claude/pitch2/dashboard_shot.jpg">    </p:cNvPr>
+          <p:cNvPr id="6" name="Image 1" descr="/home/claude/pitch2/dashboard_shot.jpg"/>
           <p:cNvPicPr>
             <a:picLocks noChangeAspect="1"/>
           </p:cNvPicPr>
@@ -3411,13 +3359,12 @@
             <a:avLst/>
           </a:prstGeom>
           <a:noFill/>
-          <a:ln/>
         </p:spPr>
         <p:txBody>
           <a:bodyPr wrap="square" rtlCol="0" anchor="ctr"/>
           <a:lstStyle/>
           <a:p>
-            <a:pPr algn="ctr" indent="0" marL="0">
+            <a:pPr marL="0" indent="0" algn="ctr">
               <a:buNone/>
             </a:pPr>
             <a:r>
@@ -3425,9 +3372,9 @@
                 <a:solidFill>
                   <a:srgbClr val="1F3350"/>
                 </a:solidFill>
-                <a:latin typeface="Times New Roman" pitchFamily="34" charset="0"/>
-                <a:ea typeface="Times New Roman" pitchFamily="34" charset="-122"/>
-                <a:cs typeface="Times New Roman" pitchFamily="34" charset="-120"/>
+                <a:latin typeface="Times New Roman" panose="02020603050405020304" pitchFamily="34" charset="0"/>
+                <a:ea typeface="Times New Roman" panose="02020603050405020304" pitchFamily="34" charset="-122"/>
+                <a:cs typeface="Times New Roman" panose="02020603050405020304" pitchFamily="34" charset="-120"/>
               </a:rPr>
               <a:t>Figure 3. Fire Commander dashboard (Node-RED)</a:t>
             </a:r>
@@ -3450,13 +3397,12 @@
             <a:avLst/>
           </a:prstGeom>
           <a:noFill/>
-          <a:ln/>
         </p:spPr>
         <p:txBody>
           <a:bodyPr wrap="square" rtlCol="0" anchor="ctr"/>
           <a:lstStyle/>
           <a:p>
-            <a:pPr algn="l" indent="0" marL="0">
+            <a:pPr marL="0" indent="0" algn="l">
               <a:buNone/>
             </a:pPr>
             <a:r>
@@ -3464,9 +3410,9 @@
                 <a:solidFill>
                   <a:srgbClr val="1F3350"/>
                 </a:solidFill>
-                <a:latin typeface="Times New Roman" pitchFamily="34" charset="0"/>
-                <a:ea typeface="Times New Roman" pitchFamily="34" charset="-122"/>
-                <a:cs typeface="Times New Roman" pitchFamily="34" charset="-120"/>
+                <a:latin typeface="Times New Roman" panose="02020603050405020304" pitchFamily="34" charset="0"/>
+                <a:ea typeface="Times New Roman" panose="02020603050405020304" pitchFamily="34" charset="-122"/>
+                <a:cs typeface="Times New Roman" panose="02020603050405020304" pitchFamily="34" charset="-120"/>
               </a:rPr>
               <a:t>Dynamic Fire Evacuation Router</a:t>
             </a:r>
@@ -3489,13 +3435,12 @@
             <a:avLst/>
           </a:prstGeom>
           <a:noFill/>
-          <a:ln/>
         </p:spPr>
         <p:txBody>
           <a:bodyPr wrap="square" rtlCol="0" anchor="ctr"/>
           <a:lstStyle/>
           <a:p>
-            <a:pPr algn="r" indent="0" marL="0">
+            <a:pPr marL="0" indent="0" algn="r">
               <a:buNone/>
             </a:pPr>
             <a:r>
@@ -3503,9 +3448,9 @@
                 <a:solidFill>
                   <a:srgbClr val="1F3350"/>
                 </a:solidFill>
-                <a:latin typeface="Times New Roman" pitchFamily="34" charset="0"/>
-                <a:ea typeface="Times New Roman" pitchFamily="34" charset="-122"/>
-                <a:cs typeface="Times New Roman" pitchFamily="34" charset="-120"/>
+                <a:latin typeface="Times New Roman" panose="02020603050405020304" pitchFamily="34" charset="0"/>
+                <a:ea typeface="Times New Roman" panose="02020603050405020304" pitchFamily="34" charset="-122"/>
+                <a:cs typeface="Times New Roman" panose="02020603050405020304" pitchFamily="34" charset="-120"/>
               </a:rPr>
               <a:t>5</a:t>
             </a:r>
@@ -3523,12 +3468,13 @@
 
 <file path=ppt/slides/slide6.xml><?xml version="1.0" encoding="utf-8"?>
 <p:sld xmlns:a="http://schemas.openxmlformats.org/drawingml/2006/main" xmlns:r="http://schemas.openxmlformats.org/officeDocument/2006/relationships" xmlns:p="http://schemas.openxmlformats.org/presentationml/2006/main">
-  <p:cSld name="Slide 6">
+  <p:cSld>
     <p:bg>
       <p:bgPr>
         <a:solidFill>
           <a:srgbClr val="FFFFFF"/>
         </a:solidFill>
+        <a:effectLst/>
       </p:bgPr>
     </p:bg>
     <p:spTree>
@@ -3560,13 +3506,12 @@
             <a:avLst/>
           </a:prstGeom>
           <a:noFill/>
-          <a:ln/>
         </p:spPr>
         <p:txBody>
           <a:bodyPr wrap="square" rtlCol="0" anchor="ctr"/>
           <a:lstStyle/>
           <a:p>
-            <a:pPr algn="l" indent="0" marL="0">
+            <a:pPr marL="0" indent="0" algn="l">
               <a:buNone/>
             </a:pPr>
             <a:r>
@@ -3574,9 +3519,9 @@
                 <a:solidFill>
                   <a:srgbClr val="1F3350"/>
                 </a:solidFill>
-                <a:latin typeface="Times New Roman" pitchFamily="34" charset="0"/>
-                <a:ea typeface="Times New Roman" pitchFamily="34" charset="-122"/>
-                <a:cs typeface="Times New Roman" pitchFamily="34" charset="-120"/>
+                <a:latin typeface="Times New Roman" panose="02020603050405020304" pitchFamily="34" charset="0"/>
+                <a:ea typeface="Times New Roman" panose="02020603050405020304" pitchFamily="34" charset="-122"/>
+                <a:cs typeface="Times New Roman" panose="02020603050405020304" pitchFamily="34" charset="-120"/>
               </a:rPr>
               <a:t>Research and references</a:t>
             </a:r>
@@ -3599,13 +3544,12 @@
             <a:avLst/>
           </a:prstGeom>
           <a:noFill/>
-          <a:ln/>
         </p:spPr>
         <p:txBody>
           <a:bodyPr wrap="square" rtlCol="0" anchor="t"/>
           <a:lstStyle/>
           <a:p>
-            <a:pPr algn="l" marL="342900" indent="-342900">
+            <a:pPr marL="342900" indent="-342900" algn="l">
               <a:spcAft>
                 <a:spcPts val="1800"/>
               </a:spcAft>
@@ -3617,16 +3561,16 @@
                 <a:solidFill>
                   <a:srgbClr val="000000"/>
                 </a:solidFill>
-                <a:latin typeface="Times New Roman" pitchFamily="34" charset="0"/>
-                <a:ea typeface="Times New Roman" pitchFamily="34" charset="-122"/>
-                <a:cs typeface="Times New Roman" pitchFamily="34" charset="-120"/>
+                <a:latin typeface="Times New Roman" panose="02020603050405020304" pitchFamily="34" charset="0"/>
+                <a:ea typeface="Times New Roman" panose="02020603050405020304" pitchFamily="34" charset="-122"/>
+                <a:cs typeface="Times New Roman" panose="02020603050405020304" pitchFamily="34" charset="-120"/>
               </a:rPr>
               <a:t>Repository: github.com/kishaunjith-S/fire-evac-router</a:t>
             </a:r>
             <a:endParaRPr lang="en-US" sz="2000" dirty="0"/>
           </a:p>
           <a:p>
-            <a:pPr algn="l" marL="342900" indent="-342900">
+            <a:pPr marL="342900" indent="-342900" algn="l">
               <a:spcAft>
                 <a:spcPts val="1800"/>
               </a:spcAft>
@@ -3638,16 +3582,16 @@
                 <a:solidFill>
                   <a:srgbClr val="000000"/>
                 </a:solidFill>
-                <a:latin typeface="Times New Roman" pitchFamily="34" charset="0"/>
-                <a:ea typeface="Times New Roman" pitchFamily="34" charset="-122"/>
-                <a:cs typeface="Times New Roman" pitchFamily="34" charset="-120"/>
+                <a:latin typeface="Times New Roman" panose="02020603050405020304" pitchFamily="34" charset="0"/>
+                <a:ea typeface="Times New Roman" panose="02020603050405020304" pitchFamily="34" charset="-122"/>
+                <a:cs typeface="Times New Roman" panose="02020603050405020304" pitchFamily="34" charset="-120"/>
               </a:rPr>
               <a:t>Debugging case study: docs/latency_debugging_notes.md</a:t>
             </a:r>
             <a:endParaRPr lang="en-US" sz="2000" dirty="0"/>
           </a:p>
           <a:p>
-            <a:pPr algn="l" marL="342900" indent="-342900">
+            <a:pPr marL="342900" indent="-342900" algn="l">
               <a:spcAft>
                 <a:spcPts val="1800"/>
               </a:spcAft>
@@ -3659,16 +3603,16 @@
                 <a:solidFill>
                   <a:srgbClr val="000000"/>
                 </a:solidFill>
-                <a:latin typeface="Times New Roman" pitchFamily="34" charset="0"/>
-                <a:ea typeface="Times New Roman" pitchFamily="34" charset="-122"/>
-                <a:cs typeface="Times New Roman" pitchFamily="34" charset="-120"/>
+                <a:latin typeface="Times New Roman" panose="02020603050405020304" pitchFamily="34" charset="0"/>
+                <a:ea typeface="Times New Roman" panose="02020603050405020304" pitchFamily="34" charset="-122"/>
+                <a:cs typeface="Times New Roman" panose="02020603050405020304" pitchFamily="34" charset="-120"/>
               </a:rPr>
               <a:t>Libraries: NetworkX, Eclipse Mosquitto, paho-mqtt, Node-RED</a:t>
             </a:r>
             <a:endParaRPr lang="en-US" sz="2000" dirty="0"/>
           </a:p>
           <a:p>
-            <a:pPr algn="l" marL="342900" indent="-342900">
+            <a:pPr marL="342900" indent="-342900" algn="l">
               <a:spcAft>
                 <a:spcPts val="1800"/>
               </a:spcAft>
@@ -3680,9 +3624,30 @@
                 <a:solidFill>
                   <a:srgbClr val="000000"/>
                 </a:solidFill>
-                <a:latin typeface="Times New Roman" pitchFamily="34" charset="0"/>
-                <a:ea typeface="Times New Roman" pitchFamily="34" charset="-122"/>
-                <a:cs typeface="Times New Roman" pitchFamily="34" charset="-120"/>
+                <a:latin typeface="Times New Roman" panose="02020603050405020304" pitchFamily="34" charset="0"/>
+                <a:ea typeface="Times New Roman" panose="02020603050405020304" pitchFamily="34" charset="-122"/>
+                <a:cs typeface="Times New Roman" panose="02020603050405020304" pitchFamily="34" charset="-120"/>
+              </a:rPr>
+              <a:t>Hardware validation: wokwi.com/projects/470617448491375617</a:t>
+            </a:r>
+            <a:endParaRPr lang="en-US" sz="2000" dirty="0"/>
+          </a:p>
+          <a:p>
+            <a:pPr marL="342900" indent="-342900" algn="l">
+              <a:spcAft>
+                <a:spcPts val="1800"/>
+              </a:spcAft>
+              <a:buSzPct val="100000"/>
+              <a:buChar char="•"/>
+            </a:pPr>
+            <a:r>
+              <a:rPr lang="en-US" sz="2000" dirty="0">
+                <a:solidFill>
+                  <a:srgbClr val="000000"/>
+                </a:solidFill>
+                <a:latin typeface="Times New Roman" panose="02020603050405020304" pitchFamily="34" charset="0"/>
+                <a:ea typeface="Times New Roman" panose="02020603050405020304" pitchFamily="34" charset="-122"/>
+                <a:cs typeface="Times New Roman" panose="02020603050405020304" pitchFamily="34" charset="-120"/>
               </a:rPr>
               <a:t>Calibration sources: NIST fire data, Kaggle smoke datasets</a:t>
             </a:r>
@@ -3705,13 +3670,12 @@
             <a:avLst/>
           </a:prstGeom>
           <a:noFill/>
-          <a:ln/>
         </p:spPr>
         <p:txBody>
           <a:bodyPr wrap="square" rtlCol="0" anchor="ctr"/>
           <a:lstStyle/>
           <a:p>
-            <a:pPr algn="l" indent="0" marL="0">
+            <a:pPr marL="0" indent="0" algn="l">
               <a:buNone/>
             </a:pPr>
             <a:r>
@@ -3719,9 +3683,9 @@
                 <a:solidFill>
                   <a:srgbClr val="1F3350"/>
                 </a:solidFill>
-                <a:latin typeface="Times New Roman" pitchFamily="34" charset="0"/>
-                <a:ea typeface="Times New Roman" pitchFamily="34" charset="-122"/>
-                <a:cs typeface="Times New Roman" pitchFamily="34" charset="-120"/>
+                <a:latin typeface="Times New Roman" panose="02020603050405020304" pitchFamily="34" charset="0"/>
+                <a:ea typeface="Times New Roman" panose="02020603050405020304" pitchFamily="34" charset="-122"/>
+                <a:cs typeface="Times New Roman" panose="02020603050405020304" pitchFamily="34" charset="-120"/>
               </a:rPr>
               <a:t>Dynamic Fire Evacuation Router</a:t>
             </a:r>
@@ -3744,13 +3708,12 @@
             <a:avLst/>
           </a:prstGeom>
           <a:noFill/>
-          <a:ln/>
         </p:spPr>
         <p:txBody>
           <a:bodyPr wrap="square" rtlCol="0" anchor="ctr"/>
           <a:lstStyle/>
           <a:p>
-            <a:pPr algn="r" indent="0" marL="0">
+            <a:pPr marL="0" indent="0" algn="r">
               <a:buNone/>
             </a:pPr>
             <a:r>
@@ -3758,9 +3721,9 @@
                 <a:solidFill>
                   <a:srgbClr val="1F3350"/>
                 </a:solidFill>
-                <a:latin typeface="Times New Roman" pitchFamily="34" charset="0"/>
-                <a:ea typeface="Times New Roman" pitchFamily="34" charset="-122"/>
-                <a:cs typeface="Times New Roman" pitchFamily="34" charset="-120"/>
+                <a:latin typeface="Times New Roman" panose="02020603050405020304" pitchFamily="34" charset="0"/>
+                <a:ea typeface="Times New Roman" panose="02020603050405020304" pitchFamily="34" charset="-122"/>
+                <a:cs typeface="Times New Roman" panose="02020603050405020304" pitchFamily="34" charset="-120"/>
               </a:rPr>
               <a:t>6</a:t>
             </a:r>
@@ -3819,7 +3782,7 @@
     </a:clrScheme>
     <a:fontScheme name="Office">
       <a:majorFont>
-        <a:latin typeface="Calibri Light" panose="020F0302020204030204"/>
+        <a:latin typeface="Calibri Light"/>
         <a:ea typeface=""/>
         <a:cs typeface=""/>
         <a:font script="Jpan" typeface="游ゴシック Light"/>
@@ -3852,26 +3815,9 @@
         <a:font script="Viet" typeface="Times New Roman"/>
         <a:font script="Uigh" typeface="Microsoft Uighur"/>
         <a:font script="Geor" typeface="Sylfaen"/>
-        <a:font script="Armn" typeface="Arial"/>
-        <a:font script="Bugi" typeface="Leelawadee UI"/>
-        <a:font script="Bopo" typeface="Microsoft JhengHei"/>
-        <a:font script="Java" typeface="Javanese Text"/>
-        <a:font script="Lisu" typeface="Segoe UI"/>
-        <a:font script="Mymr" typeface="Myanmar Text"/>
-        <a:font script="Nkoo" typeface="Ebrima"/>
-        <a:font script="Olck" typeface="Nirmala UI"/>
-        <a:font script="Osma" typeface="Ebrima"/>
-        <a:font script="Phag" typeface="Phagspa"/>
-        <a:font script="Syrn" typeface="Estrangelo Edessa"/>
-        <a:font script="Syrj" typeface="Estrangelo Edessa"/>
-        <a:font script="Syre" typeface="Estrangelo Edessa"/>
-        <a:font script="Sora" typeface="Nirmala UI"/>
-        <a:font script="Tale" typeface="Microsoft Tai Le"/>
-        <a:font script="Talu" typeface="Microsoft New Tai Lue"/>
-        <a:font script="Tfng" typeface="Ebrima"/>
       </a:majorFont>
       <a:minorFont>
-        <a:latin typeface="Calibri" panose="020F0502020204030204"/>
+        <a:latin typeface="Calibri"/>
         <a:ea typeface=""/>
         <a:cs typeface=""/>
         <a:font script="Jpan" typeface="游ゴシック"/>
@@ -3904,23 +3850,6 @@
         <a:font script="Viet" typeface="Arial"/>
         <a:font script="Uigh" typeface="Microsoft Uighur"/>
         <a:font script="Geor" typeface="Sylfaen"/>
-        <a:font script="Armn" typeface="Arial"/>
-        <a:font script="Bugi" typeface="Leelawadee UI"/>
-        <a:font script="Bopo" typeface="Microsoft JhengHei"/>
-        <a:font script="Java" typeface="Javanese Text"/>
-        <a:font script="Lisu" typeface="Segoe UI"/>
-        <a:font script="Mymr" typeface="Myanmar Text"/>
-        <a:font script="Nkoo" typeface="Ebrima"/>
-        <a:font script="Olck" typeface="Nirmala UI"/>
-        <a:font script="Osma" typeface="Ebrima"/>
-        <a:font script="Phag" typeface="Phagspa"/>
-        <a:font script="Syrn" typeface="Estrangelo Edessa"/>
-        <a:font script="Syrj" typeface="Estrangelo Edessa"/>
-        <a:font script="Syre" typeface="Estrangelo Edessa"/>
-        <a:font script="Sora" typeface="Nirmala UI"/>
-        <a:font script="Tale" typeface="Microsoft Tai Le"/>
-        <a:font script="Talu" typeface="Microsoft New Tai Lue"/>
-        <a:font script="Tfng" typeface="Ebrima"/>
       </a:minorFont>
     </a:fontScheme>
     <a:fmtScheme name="Office">
@@ -4061,8 +3990,265 @@
       </a:bgFillStyleLst>
     </a:fmtScheme>
   </a:themeElements>
-  <a:objectDefaults/>
-  <a:extraClrSchemeLst/>
+  <a:extLst>
+    <a:ext uri="{05A4C25C-085E-4340-85A3-A5531E510DB2}">
+      <thm15:themeFamily xmlns:thm15="http://schemas.microsoft.com/office/thememl/2012/main" name="Office Theme" id="{62F939B6-93AF-4DB8-9C6B-D6C7DFDC589F}" vid="{4A3C46E8-61CC-4603-A589-7422A47A8E4A}"/>
+    </a:ext>
+  </a:extLst>
+</a:theme>
+</file>
+
+<file path=ppt/theme/theme2.xml><?xml version="1.0" encoding="utf-8"?>
+<a:theme xmlns:a="http://schemas.openxmlformats.org/drawingml/2006/main" name="Office Theme">
+  <a:themeElements>
+    <a:clrScheme name="Office">
+      <a:dk1>
+        <a:sysClr val="windowText" lastClr="000000"/>
+      </a:dk1>
+      <a:lt1>
+        <a:sysClr val="window" lastClr="FFFFFF"/>
+      </a:lt1>
+      <a:dk2>
+        <a:srgbClr val="44546A"/>
+      </a:dk2>
+      <a:lt2>
+        <a:srgbClr val="E7E6E6"/>
+      </a:lt2>
+      <a:accent1>
+        <a:srgbClr val="4472C4"/>
+      </a:accent1>
+      <a:accent2>
+        <a:srgbClr val="ED7D31"/>
+      </a:accent2>
+      <a:accent3>
+        <a:srgbClr val="A5A5A5"/>
+      </a:accent3>
+      <a:accent4>
+        <a:srgbClr val="FFC000"/>
+      </a:accent4>
+      <a:accent5>
+        <a:srgbClr val="5B9BD5"/>
+      </a:accent5>
+      <a:accent6>
+        <a:srgbClr val="70AD47"/>
+      </a:accent6>
+      <a:hlink>
+        <a:srgbClr val="0563C1"/>
+      </a:hlink>
+      <a:folHlink>
+        <a:srgbClr val="954F72"/>
+      </a:folHlink>
+    </a:clrScheme>
+    <a:fontScheme name="Office">
+      <a:majorFont>
+        <a:latin typeface="Calibri Light"/>
+        <a:ea typeface=""/>
+        <a:cs typeface=""/>
+        <a:font script="Jpan" typeface="游ゴシック Light"/>
+        <a:font script="Hang" typeface="맑은 고딕"/>
+        <a:font script="Hans" typeface="等线 Light"/>
+        <a:font script="Hant" typeface="新細明體"/>
+        <a:font script="Arab" typeface="Times New Roman"/>
+        <a:font script="Hebr" typeface="Times New Roman"/>
+        <a:font script="Thai" typeface="Angsana New"/>
+        <a:font script="Ethi" typeface="Nyala"/>
+        <a:font script="Beng" typeface="Vrinda"/>
+        <a:font script="Gujr" typeface="Shruti"/>
+        <a:font script="Khmr" typeface="MoolBoran"/>
+        <a:font script="Knda" typeface="Tunga"/>
+        <a:font script="Guru" typeface="Raavi"/>
+        <a:font script="Cans" typeface="Euphemia"/>
+        <a:font script="Cher" typeface="Plantagenet Cherokee"/>
+        <a:font script="Yiii" typeface="Microsoft Yi Baiti"/>
+        <a:font script="Tibt" typeface="Microsoft Himalaya"/>
+        <a:font script="Thaa" typeface="MV Boli"/>
+        <a:font script="Deva" typeface="Mangal"/>
+        <a:font script="Telu" typeface="Gautami"/>
+        <a:font script="Taml" typeface="Latha"/>
+        <a:font script="Syrc" typeface="Estrangelo Edessa"/>
+        <a:font script="Orya" typeface="Kalinga"/>
+        <a:font script="Mlym" typeface="Kartika"/>
+        <a:font script="Laoo" typeface="DokChampa"/>
+        <a:font script="Sinh" typeface="Iskoola Pota"/>
+        <a:font script="Mong" typeface="Mongolian Baiti"/>
+        <a:font script="Viet" typeface="Times New Roman"/>
+        <a:font script="Uigh" typeface="Microsoft Uighur"/>
+        <a:font script="Geor" typeface="Sylfaen"/>
+      </a:majorFont>
+      <a:minorFont>
+        <a:latin typeface="Calibri"/>
+        <a:ea typeface=""/>
+        <a:cs typeface=""/>
+        <a:font script="Jpan" typeface="游ゴシック"/>
+        <a:font script="Hang" typeface="맑은 고딕"/>
+        <a:font script="Hans" typeface="等线"/>
+        <a:font script="Hant" typeface="新細明體"/>
+        <a:font script="Arab" typeface="Arial"/>
+        <a:font script="Hebr" typeface="Arial"/>
+        <a:font script="Thai" typeface="Cordia New"/>
+        <a:font script="Ethi" typeface="Nyala"/>
+        <a:font script="Beng" typeface="Vrinda"/>
+        <a:font script="Gujr" typeface="Shruti"/>
+        <a:font script="Khmr" typeface="DaunPenh"/>
+        <a:font script="Knda" typeface="Tunga"/>
+        <a:font script="Guru" typeface="Raavi"/>
+        <a:font script="Cans" typeface="Euphemia"/>
+        <a:font script="Cher" typeface="Plantagenet Cherokee"/>
+        <a:font script="Yiii" typeface="Microsoft Yi Baiti"/>
+        <a:font script="Tibt" typeface="Microsoft Himalaya"/>
+        <a:font script="Thaa" typeface="MV Boli"/>
+        <a:font script="Deva" typeface="Mangal"/>
+        <a:font script="Telu" typeface="Gautami"/>
+        <a:font script="Taml" typeface="Latha"/>
+        <a:font script="Syrc" typeface="Estrangelo Edessa"/>
+        <a:font script="Orya" typeface="Kalinga"/>
+        <a:font script="Mlym" typeface="Kartika"/>
+        <a:font script="Laoo" typeface="DokChampa"/>
+        <a:font script="Sinh" typeface="Iskoola Pota"/>
+        <a:font script="Mong" typeface="Mongolian Baiti"/>
+        <a:font script="Viet" typeface="Arial"/>
+        <a:font script="Uigh" typeface="Microsoft Uighur"/>
+        <a:font script="Geor" typeface="Sylfaen"/>
+      </a:minorFont>
+    </a:fontScheme>
+    <a:fmtScheme name="Office">
+      <a:fillStyleLst>
+        <a:solidFill>
+          <a:schemeClr val="phClr"/>
+        </a:solidFill>
+        <a:gradFill rotWithShape="1">
+          <a:gsLst>
+            <a:gs pos="0">
+              <a:schemeClr val="phClr">
+                <a:lumMod val="110000"/>
+                <a:satMod val="105000"/>
+                <a:tint val="67000"/>
+              </a:schemeClr>
+            </a:gs>
+            <a:gs pos="50000">
+              <a:schemeClr val="phClr">
+                <a:lumMod val="105000"/>
+                <a:satMod val="103000"/>
+                <a:tint val="73000"/>
+              </a:schemeClr>
+            </a:gs>
+            <a:gs pos="100000">
+              <a:schemeClr val="phClr">
+                <a:lumMod val="105000"/>
+                <a:satMod val="109000"/>
+                <a:tint val="81000"/>
+              </a:schemeClr>
+            </a:gs>
+          </a:gsLst>
+          <a:lin ang="5400000" scaled="0"/>
+        </a:gradFill>
+        <a:gradFill rotWithShape="1">
+          <a:gsLst>
+            <a:gs pos="0">
+              <a:schemeClr val="phClr">
+                <a:satMod val="103000"/>
+                <a:lumMod val="102000"/>
+                <a:tint val="94000"/>
+              </a:schemeClr>
+            </a:gs>
+            <a:gs pos="50000">
+              <a:schemeClr val="phClr">
+                <a:satMod val="110000"/>
+                <a:lumMod val="100000"/>
+                <a:shade val="100000"/>
+              </a:schemeClr>
+            </a:gs>
+            <a:gs pos="100000">
+              <a:schemeClr val="phClr">
+                <a:lumMod val="99000"/>
+                <a:satMod val="120000"/>
+                <a:shade val="78000"/>
+              </a:schemeClr>
+            </a:gs>
+          </a:gsLst>
+          <a:lin ang="5400000" scaled="0"/>
+        </a:gradFill>
+      </a:fillStyleLst>
+      <a:lnStyleLst>
+        <a:ln w="6350" cap="flat" cmpd="sng" algn="ctr">
+          <a:solidFill>
+            <a:schemeClr val="phClr"/>
+          </a:solidFill>
+          <a:prstDash val="solid"/>
+          <a:miter lim="800000"/>
+        </a:ln>
+        <a:ln w="12700" cap="flat" cmpd="sng" algn="ctr">
+          <a:solidFill>
+            <a:schemeClr val="phClr"/>
+          </a:solidFill>
+          <a:prstDash val="solid"/>
+          <a:miter lim="800000"/>
+        </a:ln>
+        <a:ln w="19050" cap="flat" cmpd="sng" algn="ctr">
+          <a:solidFill>
+            <a:schemeClr val="phClr"/>
+          </a:solidFill>
+          <a:prstDash val="solid"/>
+          <a:miter lim="800000"/>
+        </a:ln>
+      </a:lnStyleLst>
+      <a:effectStyleLst>
+        <a:effectStyle>
+          <a:effectLst/>
+        </a:effectStyle>
+        <a:effectStyle>
+          <a:effectLst/>
+        </a:effectStyle>
+        <a:effectStyle>
+          <a:effectLst>
+            <a:outerShdw blurRad="57150" dist="19050" dir="5400000" algn="ctr" rotWithShape="0">
+              <a:srgbClr val="000000">
+                <a:alpha val="63000"/>
+              </a:srgbClr>
+            </a:outerShdw>
+          </a:effectLst>
+        </a:effectStyle>
+      </a:effectStyleLst>
+      <a:bgFillStyleLst>
+        <a:solidFill>
+          <a:schemeClr val="phClr"/>
+        </a:solidFill>
+        <a:solidFill>
+          <a:schemeClr val="phClr">
+            <a:tint val="95000"/>
+            <a:satMod val="170000"/>
+          </a:schemeClr>
+        </a:solidFill>
+        <a:gradFill rotWithShape="1">
+          <a:gsLst>
+            <a:gs pos="0">
+              <a:schemeClr val="phClr">
+                <a:tint val="93000"/>
+                <a:satMod val="150000"/>
+                <a:shade val="98000"/>
+                <a:lumMod val="102000"/>
+              </a:schemeClr>
+            </a:gs>
+            <a:gs pos="50000">
+              <a:schemeClr val="phClr">
+                <a:tint val="98000"/>
+                <a:satMod val="130000"/>
+                <a:shade val="90000"/>
+                <a:lumMod val="103000"/>
+              </a:schemeClr>
+            </a:gs>
+            <a:gs pos="100000">
+              <a:schemeClr val="phClr">
+                <a:shade val="63000"/>
+                <a:satMod val="120000"/>
+              </a:schemeClr>
+            </a:gs>
+          </a:gsLst>
+          <a:lin ang="5400000" scaled="0"/>
+        </a:gradFill>
+      </a:bgFillStyleLst>
+    </a:fmtScheme>
+  </a:themeElements>
   <a:extLst>
     <a:ext uri="{05A4C25C-085E-4340-85A3-A5531E510DB2}">
       <thm15:themeFamily xmlns:thm15="http://schemas.microsoft.com/office/thememl/2012/main" name="Office Theme" id="{62F939B6-93AF-4DB8-9C6B-D6C7DFDC589F}" vid="{4A3C46E8-61CC-4603-A589-7422A47A8E4A}"/>

</xml_diff>